<commit_message>
Emphasize dynamic query in presentation
</commit_message>
<xml_diff>
--- a/IAM_Compliance_Dashboard_Presentation.pptx
+++ b/IAM_Compliance_Dashboard_Presentation.pptx
@@ -15,6 +15,7 @@
     <p:sldId id="263" r:id="rId14"/>
     <p:sldId id="264" r:id="rId15"/>
     <p:sldId id="265" r:id="rId16"/>
+    <p:sldId id="266" r:id="rId17"/>
   </p:sldIdLst>
   <p:sldSz cx="12191695" cy="6858000" type="screen4x3"/>
   <p:notesSz cx="6858000" cy="9144000"/>
@@ -3480,6 +3481,646 @@
             <a:avLst/>
           </a:prstGeom>
           <a:solidFill>
+            <a:srgbClr val="FFFFFF"/>
+          </a:solidFill>
+          <a:ln>
+            <a:noFill/>
+          </a:ln>
+        </p:spPr>
+        <p:style>
+          <a:lnRef idx="1">
+            <a:schemeClr val="accent1"/>
+          </a:lnRef>
+          <a:fillRef idx="3">
+            <a:schemeClr val="accent1"/>
+          </a:fillRef>
+          <a:effectRef idx="2">
+            <a:schemeClr val="accent1"/>
+          </a:effectRef>
+          <a:fontRef idx="minor">
+            <a:schemeClr val="lt1"/>
+          </a:fontRef>
+        </p:style>
+        <p:txBody>
+          <a:bodyPr rtlCol="0" anchor="ctr"/>
+          <a:lstStyle/>
+          <a:p>
+            <a:pPr algn="ctr"/>
+          </a:p>
+        </p:txBody>
+      </p:sp>
+      <p:sp>
+        <p:nvSpPr>
+          <p:cNvPr id="3" name="TextBox 2"/>
+          <p:cNvSpPr txBox="1"/>
+          <p:nvPr/>
+        </p:nvSpPr>
+        <p:spPr>
+          <a:xfrm>
+            <a:off x="594360" y="411480"/>
+            <a:ext cx="10972800" cy="502920"/>
+          </a:xfrm>
+          <a:prstGeom prst="rect">
+            <a:avLst/>
+          </a:prstGeom>
+          <a:noFill/>
+        </p:spPr>
+        <p:txBody>
+          <a:bodyPr wrap="square" lIns="36576" rIns="36576" anchor="ctr">
+            <a:spAutoFit/>
+          </a:bodyPr>
+          <a:lstStyle/>
+          <a:p>
+            <a:pPr algn="l">
+              <a:defRPr sz="2700" b="1">
+                <a:solidFill>
+                  <a:srgbClr val="162B43"/>
+                </a:solidFill>
+                <a:latin typeface="Aptos"/>
+              </a:defRPr>
+            </a:pPr>
+            <a:r>
+              <a:t>Security posture</a:t>
+            </a:r>
+          </a:p>
+        </p:txBody>
+      </p:sp>
+      <p:sp>
+        <p:nvSpPr>
+          <p:cNvPr id="4" name="TextBox 3"/>
+          <p:cNvSpPr txBox="1"/>
+          <p:nvPr/>
+        </p:nvSpPr>
+        <p:spPr>
+          <a:xfrm>
+            <a:off x="621792" y="164592"/>
+            <a:ext cx="10972800" cy="182880"/>
+          </a:xfrm>
+          <a:prstGeom prst="rect">
+            <a:avLst/>
+          </a:prstGeom>
+          <a:noFill/>
+        </p:spPr>
+        <p:txBody>
+          <a:bodyPr wrap="square" lIns="36576" rIns="36576" anchor="ctr">
+            <a:spAutoFit/>
+          </a:bodyPr>
+          <a:lstStyle/>
+          <a:p>
+            <a:pPr algn="l">
+              <a:defRPr sz="800" b="1">
+                <a:solidFill>
+                  <a:srgbClr val="009196"/>
+                </a:solidFill>
+                <a:latin typeface="Aptos"/>
+              </a:defRPr>
+            </a:pPr>
+            <a:r>
+              <a:t>IMPORTANT BOUNDARY</a:t>
+            </a:r>
+          </a:p>
+        </p:txBody>
+      </p:sp>
+      <p:sp>
+        <p:nvSpPr>
+          <p:cNvPr id="5" name="Rectangle 4"/>
+          <p:cNvSpPr/>
+          <p:nvPr/>
+        </p:nvSpPr>
+        <p:spPr>
+          <a:xfrm>
+            <a:off x="621792" y="1024128"/>
+            <a:ext cx="658368" cy="54864"/>
+          </a:xfrm>
+          <a:prstGeom prst="rect">
+            <a:avLst/>
+          </a:prstGeom>
+          <a:solidFill>
+            <a:srgbClr val="009196"/>
+          </a:solidFill>
+          <a:ln>
+            <a:noFill/>
+          </a:ln>
+        </p:spPr>
+        <p:style>
+          <a:lnRef idx="1">
+            <a:schemeClr val="accent1"/>
+          </a:lnRef>
+          <a:fillRef idx="3">
+            <a:schemeClr val="accent1"/>
+          </a:fillRef>
+          <a:effectRef idx="2">
+            <a:schemeClr val="accent1"/>
+          </a:effectRef>
+          <a:fontRef idx="minor">
+            <a:schemeClr val="lt1"/>
+          </a:fontRef>
+        </p:style>
+        <p:txBody>
+          <a:bodyPr rtlCol="0" anchor="ctr"/>
+          <a:lstStyle/>
+          <a:p>
+            <a:pPr algn="ctr"/>
+          </a:p>
+        </p:txBody>
+      </p:sp>
+      <p:sp>
+        <p:nvSpPr>
+          <p:cNvPr id="6" name="Rounded Rectangle 5"/>
+          <p:cNvSpPr/>
+          <p:nvPr/>
+        </p:nvSpPr>
+        <p:spPr>
+          <a:xfrm>
+            <a:off x="685800" y="1417320"/>
+            <a:ext cx="5212080" cy="4069080"/>
+          </a:xfrm>
+          <a:prstGeom prst="roundRect">
+            <a:avLst/>
+          </a:prstGeom>
+          <a:solidFill>
+            <a:srgbClr val="F3F7F8"/>
+          </a:solidFill>
+          <a:ln>
+            <a:solidFill>
+              <a:srgbClr val="DCE5E8"/>
+            </a:solidFill>
+          </a:ln>
+        </p:spPr>
+        <p:style>
+          <a:lnRef idx="1">
+            <a:schemeClr val="accent1"/>
+          </a:lnRef>
+          <a:fillRef idx="3">
+            <a:schemeClr val="accent1"/>
+          </a:fillRef>
+          <a:effectRef idx="2">
+            <a:schemeClr val="accent1"/>
+          </a:effectRef>
+          <a:fontRef idx="minor">
+            <a:schemeClr val="lt1"/>
+          </a:fontRef>
+        </p:style>
+        <p:txBody>
+          <a:bodyPr rtlCol="0" anchor="ctr"/>
+          <a:lstStyle/>
+          <a:p>
+            <a:pPr algn="ctr"/>
+          </a:p>
+        </p:txBody>
+      </p:sp>
+      <p:sp>
+        <p:nvSpPr>
+          <p:cNvPr id="7" name="Rectangle 6"/>
+          <p:cNvSpPr/>
+          <p:nvPr/>
+        </p:nvSpPr>
+        <p:spPr>
+          <a:xfrm>
+            <a:off x="685800" y="1417320"/>
+            <a:ext cx="73152" cy="4069080"/>
+          </a:xfrm>
+          <a:prstGeom prst="rect">
+            <a:avLst/>
+          </a:prstGeom>
+          <a:solidFill>
+            <a:srgbClr val="FAB219"/>
+          </a:solidFill>
+          <a:ln>
+            <a:noFill/>
+          </a:ln>
+        </p:spPr>
+        <p:style>
+          <a:lnRef idx="1">
+            <a:schemeClr val="accent1"/>
+          </a:lnRef>
+          <a:fillRef idx="3">
+            <a:schemeClr val="accent1"/>
+          </a:fillRef>
+          <a:effectRef idx="2">
+            <a:schemeClr val="accent1"/>
+          </a:effectRef>
+          <a:fontRef idx="minor">
+            <a:schemeClr val="lt1"/>
+          </a:fontRef>
+        </p:style>
+        <p:txBody>
+          <a:bodyPr rtlCol="0" anchor="ctr"/>
+          <a:lstStyle/>
+          <a:p>
+            <a:pPr algn="ctr"/>
+          </a:p>
+        </p:txBody>
+      </p:sp>
+      <p:sp>
+        <p:nvSpPr>
+          <p:cNvPr id="8" name="TextBox 7"/>
+          <p:cNvSpPr txBox="1"/>
+          <p:nvPr/>
+        </p:nvSpPr>
+        <p:spPr>
+          <a:xfrm>
+            <a:off x="914400" y="1563624"/>
+            <a:ext cx="4800600" cy="310896"/>
+          </a:xfrm>
+          <a:prstGeom prst="rect">
+            <a:avLst/>
+          </a:prstGeom>
+          <a:noFill/>
+        </p:spPr>
+        <p:txBody>
+          <a:bodyPr wrap="square" lIns="36576" rIns="36576" anchor="ctr">
+            <a:spAutoFit/>
+          </a:bodyPr>
+          <a:lstStyle/>
+          <a:p>
+            <a:pPr algn="l">
+              <a:defRPr sz="1500" b="1">
+                <a:solidFill>
+                  <a:srgbClr val="162B43"/>
+                </a:solidFill>
+                <a:latin typeface="Aptos"/>
+              </a:defRPr>
+            </a:pPr>
+            <a:r>
+              <a:t>Current prototype</a:t>
+            </a:r>
+          </a:p>
+        </p:txBody>
+      </p:sp>
+      <p:sp>
+        <p:nvSpPr>
+          <p:cNvPr id="9" name="TextBox 8"/>
+          <p:cNvSpPr txBox="1"/>
+          <p:nvPr/>
+        </p:nvSpPr>
+        <p:spPr>
+          <a:xfrm>
+            <a:off x="914400" y="1947672"/>
+            <a:ext cx="4800600" cy="3410712"/>
+          </a:xfrm>
+          <a:prstGeom prst="rect">
+            <a:avLst/>
+          </a:prstGeom>
+          <a:noFill/>
+        </p:spPr>
+        <p:txBody>
+          <a:bodyPr wrap="square" lIns="36576" rIns="36576" anchor="ctr">
+            <a:spAutoFit/>
+          </a:bodyPr>
+          <a:lstStyle/>
+          <a:p>
+            <a:pPr algn="l">
+              <a:defRPr sz="1500" b="0">
+                <a:solidFill>
+                  <a:srgbClr val="212D3A"/>
+                </a:solidFill>
+                <a:latin typeface="Aptos"/>
+              </a:defRPr>
+            </a:pPr>
+            <a:r>
+              <a:t>• Demo credentials in project data</a:t>
+            </a:r>
+            <a:br/>
+            <a:r>
+              <a:t>• Session-based browser state</a:t>
+            </a:r>
+            <a:br/>
+            <a:r>
+              <a:t>• CSV-backed sample data</a:t>
+            </a:r>
+            <a:br/>
+            <a:r>
+              <a:t>• UI role filtering</a:t>
+            </a:r>
+            <a:br/>
+            <a:r>
+              <a:t>• Suitable for non-sensitive demonstrations</a:t>
+            </a:r>
+          </a:p>
+        </p:txBody>
+      </p:sp>
+      <p:sp>
+        <p:nvSpPr>
+          <p:cNvPr id="10" name="Rounded Rectangle 9"/>
+          <p:cNvSpPr/>
+          <p:nvPr/>
+        </p:nvSpPr>
+        <p:spPr>
+          <a:xfrm>
+            <a:off x="6263640" y="1417320"/>
+            <a:ext cx="5212080" cy="4069080"/>
+          </a:xfrm>
+          <a:prstGeom prst="roundRect">
+            <a:avLst/>
+          </a:prstGeom>
+          <a:solidFill>
+            <a:srgbClr val="F3F7F8"/>
+          </a:solidFill>
+          <a:ln>
+            <a:solidFill>
+              <a:srgbClr val="DCE5E8"/>
+            </a:solidFill>
+          </a:ln>
+        </p:spPr>
+        <p:style>
+          <a:lnRef idx="1">
+            <a:schemeClr val="accent1"/>
+          </a:lnRef>
+          <a:fillRef idx="3">
+            <a:schemeClr val="accent1"/>
+          </a:fillRef>
+          <a:effectRef idx="2">
+            <a:schemeClr val="accent1"/>
+          </a:effectRef>
+          <a:fontRef idx="minor">
+            <a:schemeClr val="lt1"/>
+          </a:fontRef>
+        </p:style>
+        <p:txBody>
+          <a:bodyPr rtlCol="0" anchor="ctr"/>
+          <a:lstStyle/>
+          <a:p>
+            <a:pPr algn="ctr"/>
+          </a:p>
+        </p:txBody>
+      </p:sp>
+      <p:sp>
+        <p:nvSpPr>
+          <p:cNvPr id="11" name="Rectangle 10"/>
+          <p:cNvSpPr/>
+          <p:nvPr/>
+        </p:nvSpPr>
+        <p:spPr>
+          <a:xfrm>
+            <a:off x="6263640" y="1417320"/>
+            <a:ext cx="73152" cy="4069080"/>
+          </a:xfrm>
+          <a:prstGeom prst="rect">
+            <a:avLst/>
+          </a:prstGeom>
+          <a:solidFill>
+            <a:srgbClr val="0CA30C"/>
+          </a:solidFill>
+          <a:ln>
+            <a:noFill/>
+          </a:ln>
+        </p:spPr>
+        <p:style>
+          <a:lnRef idx="1">
+            <a:schemeClr val="accent1"/>
+          </a:lnRef>
+          <a:fillRef idx="3">
+            <a:schemeClr val="accent1"/>
+          </a:fillRef>
+          <a:effectRef idx="2">
+            <a:schemeClr val="accent1"/>
+          </a:effectRef>
+          <a:fontRef idx="minor">
+            <a:schemeClr val="lt1"/>
+          </a:fontRef>
+        </p:style>
+        <p:txBody>
+          <a:bodyPr rtlCol="0" anchor="ctr"/>
+          <a:lstStyle/>
+          <a:p>
+            <a:pPr algn="ctr"/>
+          </a:p>
+        </p:txBody>
+      </p:sp>
+      <p:sp>
+        <p:nvSpPr>
+          <p:cNvPr id="12" name="TextBox 11"/>
+          <p:cNvSpPr txBox="1"/>
+          <p:nvPr/>
+        </p:nvSpPr>
+        <p:spPr>
+          <a:xfrm>
+            <a:off x="6492240" y="1563624"/>
+            <a:ext cx="4800600" cy="310896"/>
+          </a:xfrm>
+          <a:prstGeom prst="rect">
+            <a:avLst/>
+          </a:prstGeom>
+          <a:noFill/>
+        </p:spPr>
+        <p:txBody>
+          <a:bodyPr wrap="square" lIns="36576" rIns="36576" anchor="ctr">
+            <a:spAutoFit/>
+          </a:bodyPr>
+          <a:lstStyle/>
+          <a:p>
+            <a:pPr algn="l">
+              <a:defRPr sz="1500" b="1">
+                <a:solidFill>
+                  <a:srgbClr val="162B43"/>
+                </a:solidFill>
+                <a:latin typeface="Aptos"/>
+              </a:defRPr>
+            </a:pPr>
+            <a:r>
+              <a:t>Production target</a:t>
+            </a:r>
+          </a:p>
+        </p:txBody>
+      </p:sp>
+      <p:sp>
+        <p:nvSpPr>
+          <p:cNvPr id="13" name="TextBox 12"/>
+          <p:cNvSpPr txBox="1"/>
+          <p:nvPr/>
+        </p:nvSpPr>
+        <p:spPr>
+          <a:xfrm>
+            <a:off x="6492240" y="1947672"/>
+            <a:ext cx="4800600" cy="3410712"/>
+          </a:xfrm>
+          <a:prstGeom prst="rect">
+            <a:avLst/>
+          </a:prstGeom>
+          <a:noFill/>
+        </p:spPr>
+        <p:txBody>
+          <a:bodyPr wrap="square" lIns="36576" rIns="36576" anchor="ctr">
+            <a:spAutoFit/>
+          </a:bodyPr>
+          <a:lstStyle/>
+          <a:p>
+            <a:pPr algn="l">
+              <a:defRPr sz="1500" b="0">
+                <a:solidFill>
+                  <a:srgbClr val="212D3A"/>
+                </a:solidFill>
+                <a:latin typeface="Aptos"/>
+              </a:defRPr>
+            </a:pPr>
+            <a:r>
+              <a:t>• Entra ID / Okta SSO and MFA</a:t>
+            </a:r>
+            <a:br/>
+            <a:r>
+              <a:t>• Server-side signed sessions</a:t>
+            </a:r>
+            <a:br/>
+            <a:r>
+              <a:t>• Backend authorization on callbacks</a:t>
+            </a:r>
+            <a:br/>
+            <a:r>
+              <a:t>• Hashed credentials or no local passwords</a:t>
+            </a:r>
+            <a:br/>
+            <a:r>
+              <a:t>• Secure database / APIs</a:t>
+            </a:r>
+            <a:br/>
+            <a:r>
+              <a:t>• Audit logs, secrets management, private hosting</a:t>
+            </a:r>
+          </a:p>
+        </p:txBody>
+      </p:sp>
+      <p:sp>
+        <p:nvSpPr>
+          <p:cNvPr id="14" name="TextBox 13"/>
+          <p:cNvSpPr txBox="1"/>
+          <p:nvPr/>
+        </p:nvSpPr>
+        <p:spPr>
+          <a:xfrm>
+            <a:off x="914400" y="5760720"/>
+            <a:ext cx="10332720" cy="365760"/>
+          </a:xfrm>
+          <a:prstGeom prst="rect">
+            <a:avLst/>
+          </a:prstGeom>
+          <a:noFill/>
+        </p:spPr>
+        <p:txBody>
+          <a:bodyPr wrap="square" lIns="36576" rIns="36576" anchor="ctr">
+            <a:spAutoFit/>
+          </a:bodyPr>
+          <a:lstStyle/>
+          <a:p>
+            <a:pPr algn="ctr">
+              <a:defRPr sz="1500" b="1">
+                <a:solidFill>
+                  <a:srgbClr val="162B43"/>
+                </a:solidFill>
+                <a:latin typeface="Aptos"/>
+              </a:defRPr>
+            </a:pPr>
+            <a:r>
+              <a:t>Conclusion: Dash is a reasonable internal dashboard framework; this implementation requires hardening before restricted production use.</a:t>
+            </a:r>
+          </a:p>
+        </p:txBody>
+      </p:sp>
+      <p:sp>
+        <p:nvSpPr>
+          <p:cNvPr id="15" name="TextBox 14"/>
+          <p:cNvSpPr txBox="1"/>
+          <p:nvPr/>
+        </p:nvSpPr>
+        <p:spPr>
+          <a:xfrm>
+            <a:off x="621792" y="6510528"/>
+            <a:ext cx="3657600" cy="164592"/>
+          </a:xfrm>
+          <a:prstGeom prst="rect">
+            <a:avLst/>
+          </a:prstGeom>
+          <a:noFill/>
+        </p:spPr>
+        <p:txBody>
+          <a:bodyPr wrap="square" lIns="36576" rIns="36576" anchor="ctr">
+            <a:spAutoFit/>
+          </a:bodyPr>
+          <a:lstStyle/>
+          <a:p>
+            <a:pPr algn="l">
+              <a:defRPr sz="800" b="0">
+                <a:solidFill>
+                  <a:srgbClr val="5D6C7B"/>
+                </a:solidFill>
+                <a:latin typeface="Aptos"/>
+              </a:defRPr>
+            </a:pPr>
+            <a:r>
+              <a:t>IAM Compliance Dashboard</a:t>
+            </a:r>
+          </a:p>
+        </p:txBody>
+      </p:sp>
+      <p:sp>
+        <p:nvSpPr>
+          <p:cNvPr id="16" name="TextBox 15"/>
+          <p:cNvSpPr txBox="1"/>
+          <p:nvPr/>
+        </p:nvSpPr>
+        <p:spPr>
+          <a:xfrm>
+            <a:off x="11155680" y="6510528"/>
+            <a:ext cx="411480" cy="164592"/>
+          </a:xfrm>
+          <a:prstGeom prst="rect">
+            <a:avLst/>
+          </a:prstGeom>
+          <a:noFill/>
+        </p:spPr>
+        <p:txBody>
+          <a:bodyPr wrap="square" lIns="36576" rIns="36576" anchor="ctr">
+            <a:spAutoFit/>
+          </a:bodyPr>
+          <a:lstStyle/>
+          <a:p>
+            <a:pPr algn="r">
+              <a:defRPr sz="800" b="0">
+                <a:solidFill>
+                  <a:srgbClr val="5D6C7B"/>
+                </a:solidFill>
+                <a:latin typeface="Aptos"/>
+              </a:defRPr>
+            </a:pPr>
+            <a:r>
+              <a:t>10</a:t>
+            </a:r>
+          </a:p>
+        </p:txBody>
+      </p:sp>
+    </p:spTree>
+  </p:cSld>
+  <p:clrMapOvr>
+    <a:masterClrMapping/>
+  </p:clrMapOvr>
+</p:sld>
+</file>
+
+<file path=ppt/slides/slide11.xml><?xml version="1.0" encoding="utf-8"?>
+<p:sld xmlns:a="http://schemas.openxmlformats.org/drawingml/2006/main" xmlns:p="http://schemas.openxmlformats.org/presentationml/2006/main" xmlns:r="http://schemas.openxmlformats.org/officeDocument/2006/relationships">
+  <p:cSld>
+    <p:spTree>
+      <p:nvGrpSpPr>
+        <p:cNvPr id="1" name=""/>
+        <p:cNvGrpSpPr/>
+        <p:nvPr/>
+      </p:nvGrpSpPr>
+      <p:grpSpPr/>
+      <p:sp>
+        <p:nvSpPr>
+          <p:cNvPr id="2" name="Rectangle 1"/>
+          <p:cNvSpPr/>
+          <p:nvPr/>
+        </p:nvSpPr>
+        <p:spPr>
+          <a:xfrm>
+            <a:off x="0" y="0"/>
+            <a:ext cx="12191695" cy="6858000"/>
+          </a:xfrm>
+          <a:prstGeom prst="rect">
+            <a:avLst/>
+          </a:prstGeom>
+          <a:solidFill>
             <a:srgbClr val="162B43"/>
           </a:solidFill>
           <a:ln>
@@ -8702,7 +9343,7 @@
               </a:defRPr>
             </a:pPr>
             <a:r>
-              <a:t>Role-based operating model</a:t>
+              <a:t>Dynamic Query: the differentiator</a:t>
             </a:r>
           </a:p>
         </p:txBody>
@@ -8738,7 +9379,7 @@
               </a:defRPr>
             </a:pPr>
             <a:r>
-              <a:t>WHO USES IT</a:t>
+              <a:t>UNIQUE SEARCH AND EXPLORATION</a:t>
             </a:r>
           </a:p>
         </p:txBody>
@@ -8794,8 +9435,8 @@
         </p:nvSpPr>
         <p:spPr>
           <a:xfrm>
-            <a:off x="1005840" y="1417320"/>
-            <a:ext cx="10149840" cy="822960"/>
+            <a:off x="685800" y="1417320"/>
+            <a:ext cx="3429000" cy="4160520"/>
           </a:xfrm>
           <a:prstGeom prst="roundRect">
             <a:avLst/>
@@ -8839,14 +9480,14 @@
         </p:nvSpPr>
         <p:spPr>
           <a:xfrm>
-            <a:off x="1005840" y="1417320"/>
-            <a:ext cx="146304" cy="822960"/>
+            <a:off x="685800" y="1417320"/>
+            <a:ext cx="73152" cy="4160520"/>
           </a:xfrm>
           <a:prstGeom prst="rect">
             <a:avLst/>
           </a:prstGeom>
           <a:solidFill>
-            <a:srgbClr val="D03B3B"/>
+            <a:srgbClr val="009196"/>
           </a:solidFill>
           <a:ln>
             <a:noFill/>
@@ -8882,8 +9523,8 @@
         </p:nvSpPr>
         <p:spPr>
           <a:xfrm>
-            <a:off x="1417320" y="1527048"/>
-            <a:ext cx="2194560" cy="274320"/>
+            <a:off x="914400" y="1563624"/>
+            <a:ext cx="3017520" cy="310896"/>
           </a:xfrm>
           <a:prstGeom prst="rect">
             <a:avLst/>
@@ -8897,7 +9538,7 @@
           <a:lstStyle/>
           <a:p>
             <a:pPr algn="l">
-              <a:defRPr sz="1700" b="1">
+              <a:defRPr sz="1500" b="1">
                 <a:solidFill>
                   <a:srgbClr val="162B43"/>
                 </a:solidFill>
@@ -8905,7 +9546,7 @@
               </a:defRPr>
             </a:pPr>
             <a:r>
-              <a:t>Executive</a:t>
+              <a:t>Search across domains</a:t>
             </a:r>
           </a:p>
         </p:txBody>
@@ -8918,8 +9559,8 @@
         </p:nvSpPr>
         <p:spPr>
           <a:xfrm>
-            <a:off x="3657600" y="1527048"/>
-            <a:ext cx="6949440" cy="274320"/>
+            <a:off x="914400" y="1947672"/>
+            <a:ext cx="3017520" cy="3502152"/>
           </a:xfrm>
           <a:prstGeom prst="rect">
             <a:avLst/>
@@ -8933,7 +9574,7 @@
           <a:lstStyle/>
           <a:p>
             <a:pPr algn="l">
-              <a:defRPr sz="1500" b="0">
+              <a:defRPr sz="1400" b="0">
                 <a:solidFill>
                   <a:srgbClr val="212D3A"/>
                 </a:solidFill>
@@ -8941,7 +9582,12 @@
               </a:defRPr>
             </a:pPr>
             <a:r>
-              <a:t>Enterprise posture and key findings</a:t>
+              <a:t>Choose any IAM or asset dataset, then filter by a relevant column and value.</a:t>
+            </a:r>
+            <a:br/>
+            <a:br/>
+            <a:r>
+              <a:t>One experience spans identities, infrastructure, applications, and break-glass resources.</a:t>
             </a:r>
           </a:p>
         </p:txBody>
@@ -8954,8 +9600,8 @@
         </p:nvSpPr>
         <p:spPr>
           <a:xfrm>
-            <a:off x="1005840" y="2514600"/>
-            <a:ext cx="10149840" cy="822960"/>
+            <a:off x="4389120" y="1417320"/>
+            <a:ext cx="3429000" cy="4160520"/>
           </a:xfrm>
           <a:prstGeom prst="roundRect">
             <a:avLst/>
@@ -8999,14 +9645,14 @@
         </p:nvSpPr>
         <p:spPr>
           <a:xfrm>
-            <a:off x="1005840" y="2514600"/>
-            <a:ext cx="146304" cy="822960"/>
+            <a:off x="4389120" y="1417320"/>
+            <a:ext cx="73152" cy="4160520"/>
           </a:xfrm>
           <a:prstGeom prst="rect">
             <a:avLst/>
           </a:prstGeom>
           <a:solidFill>
-            <a:srgbClr val="FAB219"/>
+            <a:srgbClr val="2A78D6"/>
           </a:solidFill>
           <a:ln>
             <a:noFill/>
@@ -9042,8 +9688,8 @@
         </p:nvSpPr>
         <p:spPr>
           <a:xfrm>
-            <a:off x="1417320" y="2624328"/>
-            <a:ext cx="2194560" cy="274320"/>
+            <a:off x="4617720" y="1563624"/>
+            <a:ext cx="3017520" cy="310896"/>
           </a:xfrm>
           <a:prstGeom prst="rect">
             <a:avLst/>
@@ -9057,7 +9703,7 @@
           <a:lstStyle/>
           <a:p>
             <a:pPr algn="l">
-              <a:defRPr sz="1700" b="1">
+              <a:defRPr sz="1500" b="1">
                 <a:solidFill>
                   <a:srgbClr val="162B43"/>
                 </a:solidFill>
@@ -9065,7 +9711,7 @@
               </a:defRPr>
             </a:pPr>
             <a:r>
-              <a:t>Leadership</a:t>
+              <a:t>Turn records into insight</a:t>
             </a:r>
           </a:p>
         </p:txBody>
@@ -9078,8 +9724,8 @@
         </p:nvSpPr>
         <p:spPr>
           <a:xfrm>
-            <a:off x="3657600" y="2624328"/>
-            <a:ext cx="6949440" cy="274320"/>
+            <a:off x="4617720" y="1947672"/>
+            <a:ext cx="3017520" cy="3502152"/>
           </a:xfrm>
           <a:prstGeom prst="rect">
             <a:avLst/>
@@ -9093,7 +9739,7 @@
           <a:lstStyle/>
           <a:p>
             <a:pPr algn="l">
-              <a:defRPr sz="1500" b="0">
+              <a:defRPr sz="1400" b="0">
                 <a:solidFill>
                   <a:srgbClr val="212D3A"/>
                 </a:solidFill>
@@ -9101,7 +9747,12 @@
               </a:defRPr>
             </a:pPr>
             <a:r>
-              <a:t>Cross-domain compliance oversight</a:t>
+              <a:t>Group results by business unit, environment, account type, asset type, or other available field.</a:t>
+            </a:r>
+            <a:br/>
+            <a:br/>
+            <a:r>
+              <a:t>Instantly see compliance and risk patterns in charts.</a:t>
             </a:r>
           </a:p>
         </p:txBody>
@@ -9114,8 +9765,8 @@
         </p:nvSpPr>
         <p:spPr>
           <a:xfrm>
-            <a:off x="1005840" y="3611880"/>
-            <a:ext cx="10149840" cy="822960"/>
+            <a:off x="8092440" y="1417320"/>
+            <a:ext cx="3429000" cy="4160520"/>
           </a:xfrm>
           <a:prstGeom prst="roundRect">
             <a:avLst/>
@@ -9159,168 +9810,8 @@
         </p:nvSpPr>
         <p:spPr>
           <a:xfrm>
-            <a:off x="1005840" y="3611880"/>
-            <a:ext cx="146304" cy="822960"/>
-          </a:xfrm>
-          <a:prstGeom prst="rect">
-            <a:avLst/>
-          </a:prstGeom>
-          <a:solidFill>
-            <a:srgbClr val="2A78D6"/>
-          </a:solidFill>
-          <a:ln>
-            <a:noFill/>
-          </a:ln>
-        </p:spPr>
-        <p:style>
-          <a:lnRef idx="1">
-            <a:schemeClr val="accent1"/>
-          </a:lnRef>
-          <a:fillRef idx="3">
-            <a:schemeClr val="accent1"/>
-          </a:fillRef>
-          <a:effectRef idx="2">
-            <a:schemeClr val="accent1"/>
-          </a:effectRef>
-          <a:fontRef idx="minor">
-            <a:schemeClr val="lt1"/>
-          </a:fontRef>
-        </p:style>
-        <p:txBody>
-          <a:bodyPr rtlCol="0" anchor="ctr"/>
-          <a:lstStyle/>
-          <a:p>
-            <a:pPr algn="ctr"/>
-          </a:p>
-        </p:txBody>
-      </p:sp>
-      <p:sp>
-        <p:nvSpPr>
-          <p:cNvPr id="16" name="TextBox 15"/>
-          <p:cNvSpPr txBox="1"/>
-          <p:nvPr/>
-        </p:nvSpPr>
-        <p:spPr>
-          <a:xfrm>
-            <a:off x="1417320" y="3721608"/>
-            <a:ext cx="2194560" cy="274320"/>
-          </a:xfrm>
-          <a:prstGeom prst="rect">
-            <a:avLst/>
-          </a:prstGeom>
-          <a:noFill/>
-        </p:spPr>
-        <p:txBody>
-          <a:bodyPr wrap="square" lIns="36576" rIns="36576" anchor="ctr">
-            <a:spAutoFit/>
-          </a:bodyPr>
-          <a:lstStyle/>
-          <a:p>
-            <a:pPr algn="l">
-              <a:defRPr sz="1700" b="1">
-                <a:solidFill>
-                  <a:srgbClr val="162B43"/>
-                </a:solidFill>
-                <a:latin typeface="Aptos"/>
-              </a:defRPr>
-            </a:pPr>
-            <a:r>
-              <a:t>Operations</a:t>
-            </a:r>
-          </a:p>
-        </p:txBody>
-      </p:sp>
-      <p:sp>
-        <p:nvSpPr>
-          <p:cNvPr id="17" name="TextBox 16"/>
-          <p:cNvSpPr txBox="1"/>
-          <p:nvPr/>
-        </p:nvSpPr>
-        <p:spPr>
-          <a:xfrm>
-            <a:off x="3657600" y="3721608"/>
-            <a:ext cx="6949440" cy="274320"/>
-          </a:xfrm>
-          <a:prstGeom prst="rect">
-            <a:avLst/>
-          </a:prstGeom>
-          <a:noFill/>
-        </p:spPr>
-        <p:txBody>
-          <a:bodyPr wrap="square" lIns="36576" rIns="36576" anchor="ctr">
-            <a:spAutoFit/>
-          </a:bodyPr>
-          <a:lstStyle/>
-          <a:p>
-            <a:pPr algn="l">
-              <a:defRPr sz="1500" b="0">
-                <a:solidFill>
-                  <a:srgbClr val="212D3A"/>
-                </a:solidFill>
-                <a:latin typeface="Aptos"/>
-              </a:defRPr>
-            </a:pPr>
-            <a:r>
-              <a:t>Detailed records and remediation</a:t>
-            </a:r>
-          </a:p>
-        </p:txBody>
-      </p:sp>
-      <p:sp>
-        <p:nvSpPr>
-          <p:cNvPr id="18" name="Rounded Rectangle 17"/>
-          <p:cNvSpPr/>
-          <p:nvPr/>
-        </p:nvSpPr>
-        <p:spPr>
-          <a:xfrm>
-            <a:off x="1005840" y="4709159"/>
-            <a:ext cx="10149840" cy="822960"/>
-          </a:xfrm>
-          <a:prstGeom prst="roundRect">
-            <a:avLst/>
-          </a:prstGeom>
-          <a:solidFill>
-            <a:srgbClr val="F3F7F8"/>
-          </a:solidFill>
-          <a:ln>
-            <a:solidFill>
-              <a:srgbClr val="DCE5E8"/>
-            </a:solidFill>
-          </a:ln>
-        </p:spPr>
-        <p:style>
-          <a:lnRef idx="1">
-            <a:schemeClr val="accent1"/>
-          </a:lnRef>
-          <a:fillRef idx="3">
-            <a:schemeClr val="accent1"/>
-          </a:fillRef>
-          <a:effectRef idx="2">
-            <a:schemeClr val="accent1"/>
-          </a:effectRef>
-          <a:fontRef idx="minor">
-            <a:schemeClr val="lt1"/>
-          </a:fontRef>
-        </p:style>
-        <p:txBody>
-          <a:bodyPr rtlCol="0" anchor="ctr"/>
-          <a:lstStyle/>
-          <a:p>
-            <a:pPr algn="ctr"/>
-          </a:p>
-        </p:txBody>
-      </p:sp>
-      <p:sp>
-        <p:nvSpPr>
-          <p:cNvPr id="19" name="Rectangle 18"/>
-          <p:cNvSpPr/>
-          <p:nvPr/>
-        </p:nvSpPr>
-        <p:spPr>
-          <a:xfrm>
-            <a:off x="1005840" y="4709159"/>
-            <a:ext cx="146304" cy="822960"/>
+            <a:off x="8092440" y="1417320"/>
+            <a:ext cx="73152" cy="4160520"/>
           </a:xfrm>
           <a:prstGeom prst="rect">
             <a:avLst/>
@@ -9356,14 +9847,14 @@
       </p:sp>
       <p:sp>
         <p:nvSpPr>
-          <p:cNvPr id="20" name="TextBox 19"/>
-          <p:cNvSpPr txBox="1"/>
-          <p:nvPr/>
-        </p:nvSpPr>
-        <p:spPr>
-          <a:xfrm>
-            <a:off x="1417320" y="4818888"/>
-            <a:ext cx="2194560" cy="274320"/>
+          <p:cNvPr id="16" name="TextBox 15"/>
+          <p:cNvSpPr txBox="1"/>
+          <p:nvPr/>
+        </p:nvSpPr>
+        <p:spPr>
+          <a:xfrm>
+            <a:off x="8321040" y="1563624"/>
+            <a:ext cx="3017520" cy="310896"/>
           </a:xfrm>
           <a:prstGeom prst="rect">
             <a:avLst/>
@@ -9377,6 +9868,83 @@
           <a:lstStyle/>
           <a:p>
             <a:pPr algn="l">
+              <a:defRPr sz="1500" b="1">
+                <a:solidFill>
+                  <a:srgbClr val="162B43"/>
+                </a:solidFill>
+                <a:latin typeface="Aptos"/>
+              </a:defRPr>
+            </a:pPr>
+            <a:r>
+              <a:t>Take the result with you</a:t>
+            </a:r>
+          </a:p>
+        </p:txBody>
+      </p:sp>
+      <p:sp>
+        <p:nvSpPr>
+          <p:cNvPr id="17" name="TextBox 16"/>
+          <p:cNvSpPr txBox="1"/>
+          <p:nvPr/>
+        </p:nvSpPr>
+        <p:spPr>
+          <a:xfrm>
+            <a:off x="8321040" y="1947672"/>
+            <a:ext cx="3017520" cy="3502152"/>
+          </a:xfrm>
+          <a:prstGeom prst="rect">
+            <a:avLst/>
+          </a:prstGeom>
+          <a:noFill/>
+        </p:spPr>
+        <p:txBody>
+          <a:bodyPr wrap="square" lIns="36576" rIns="36576" anchor="ctr">
+            <a:spAutoFit/>
+          </a:bodyPr>
+          <a:lstStyle/>
+          <a:p>
+            <a:pPr algn="l">
+              <a:defRPr sz="1400" b="0">
+                <a:solidFill>
+                  <a:srgbClr val="212D3A"/>
+                </a:solidFill>
+                <a:latin typeface="Aptos"/>
+              </a:defRPr>
+            </a:pPr>
+            <a:r>
+              <a:t>Review the filtered table, then export the exact query result to CSV or Excel.</a:t>
+            </a:r>
+            <a:br/>
+            <a:br/>
+            <a:r>
+              <a:t>This supports investigations, evidence gathering, and focused remediation.</a:t>
+            </a:r>
+          </a:p>
+        </p:txBody>
+      </p:sp>
+      <p:sp>
+        <p:nvSpPr>
+          <p:cNvPr id="18" name="TextBox 17"/>
+          <p:cNvSpPr txBox="1"/>
+          <p:nvPr/>
+        </p:nvSpPr>
+        <p:spPr>
+          <a:xfrm>
+            <a:off x="914400" y="5806440"/>
+            <a:ext cx="10332720" cy="320040"/>
+          </a:xfrm>
+          <a:prstGeom prst="rect">
+            <a:avLst/>
+          </a:prstGeom>
+          <a:noFill/>
+        </p:spPr>
+        <p:txBody>
+          <a:bodyPr wrap="square" lIns="36576" rIns="36576" anchor="ctr">
+            <a:spAutoFit/>
+          </a:bodyPr>
+          <a:lstStyle/>
+          <a:p>
+            <a:pPr algn="ctr">
               <a:defRPr sz="1700" b="1">
                 <a:solidFill>
                   <a:srgbClr val="162B43"/>
@@ -9385,86 +9953,14 @@
               </a:defRPr>
             </a:pPr>
             <a:r>
-              <a:t>Admin</a:t>
-            </a:r>
-          </a:p>
-        </p:txBody>
-      </p:sp>
-      <p:sp>
-        <p:nvSpPr>
-          <p:cNvPr id="21" name="TextBox 20"/>
-          <p:cNvSpPr txBox="1"/>
-          <p:nvPr/>
-        </p:nvSpPr>
-        <p:spPr>
-          <a:xfrm>
-            <a:off x="3657600" y="4818888"/>
-            <a:ext cx="6949440" cy="274320"/>
-          </a:xfrm>
-          <a:prstGeom prst="rect">
-            <a:avLst/>
-          </a:prstGeom>
-          <a:noFill/>
-        </p:spPr>
-        <p:txBody>
-          <a:bodyPr wrap="square" lIns="36576" rIns="36576" anchor="ctr">
-            <a:spAutoFit/>
-          </a:bodyPr>
-          <a:lstStyle/>
-          <a:p>
-            <a:pPr algn="l">
-              <a:defRPr sz="1500" b="0">
-                <a:solidFill>
-                  <a:srgbClr val="212D3A"/>
-                </a:solidFill>
-                <a:latin typeface="Aptos"/>
-              </a:defRPr>
-            </a:pPr>
-            <a:r>
-              <a:t>Field visibility and user registry</a:t>
-            </a:r>
-          </a:p>
-        </p:txBody>
-      </p:sp>
-      <p:sp>
-        <p:nvSpPr>
-          <p:cNvPr id="22" name="TextBox 21"/>
-          <p:cNvSpPr txBox="1"/>
-          <p:nvPr/>
-        </p:nvSpPr>
-        <p:spPr>
-          <a:xfrm>
-            <a:off x="1005840" y="5715000"/>
-            <a:ext cx="10058400" cy="320040"/>
-          </a:xfrm>
-          <a:prstGeom prst="rect">
-            <a:avLst/>
-          </a:prstGeom>
-          <a:noFill/>
-        </p:spPr>
-        <p:txBody>
-          <a:bodyPr wrap="square" lIns="36576" rIns="36576" anchor="ctr">
-            <a:spAutoFit/>
-          </a:bodyPr>
-          <a:lstStyle/>
-          <a:p>
-            <a:pPr algn="ctr">
-              <a:defRPr sz="1500" b="0">
-                <a:solidFill>
-                  <a:srgbClr val="5D6C7B"/>
-                </a:solidFill>
-                <a:latin typeface="Aptos"/>
-              </a:defRPr>
-            </a:pPr>
-            <a:r>
-              <a:t>Visibility is tailored by role; production authorization should be enforced server-side as well.</a:t>
-            </a:r>
-          </a:p>
-        </p:txBody>
-      </p:sp>
-      <p:sp>
-        <p:nvSpPr>
-          <p:cNvPr id="23" name="TextBox 22"/>
+              <a:t>Workflow: Select dataset  &gt;  Filter  &gt;  Group  &gt;  Visualize  &gt;  Export</a:t>
+            </a:r>
+          </a:p>
+        </p:txBody>
+      </p:sp>
+      <p:sp>
+        <p:nvSpPr>
+          <p:cNvPr id="19" name="TextBox 18"/>
           <p:cNvSpPr txBox="1"/>
           <p:nvPr/>
         </p:nvSpPr>
@@ -9500,7 +9996,7 @@
       </p:sp>
       <p:sp>
         <p:nvSpPr>
-          <p:cNvPr id="24" name="TextBox 23"/>
+          <p:cNvPr id="20" name="TextBox 19"/>
           <p:cNvSpPr txBox="1"/>
           <p:nvPr/>
         </p:nvSpPr>
@@ -9626,7 +10122,7 @@
               </a:defRPr>
             </a:pPr>
             <a:r>
-              <a:t>Executive view and metrics</a:t>
+              <a:t>Role-based operating model</a:t>
             </a:r>
           </a:p>
         </p:txBody>
@@ -9662,7 +10158,7 @@
               </a:defRPr>
             </a:pPr>
             <a:r>
-              <a:t>DECISION SUPPORT</a:t>
+              <a:t>WHO USES IT</a:t>
             </a:r>
           </a:p>
         </p:txBody>
@@ -9718,8 +10214,8 @@
         </p:nvSpPr>
         <p:spPr>
           <a:xfrm>
-            <a:off x="777240" y="1508760"/>
-            <a:ext cx="2423160" cy="1508760"/>
+            <a:off x="1005840" y="1417320"/>
+            <a:ext cx="10149840" cy="822960"/>
           </a:xfrm>
           <a:prstGeom prst="roundRect">
             <a:avLst/>
@@ -9757,37 +10253,44 @@
       </p:sp>
       <p:sp>
         <p:nvSpPr>
-          <p:cNvPr id="7" name="TextBox 6"/>
-          <p:cNvSpPr txBox="1"/>
-          <p:nvPr/>
-        </p:nvSpPr>
-        <p:spPr>
-          <a:xfrm>
-            <a:off x="914400" y="1719072"/>
-            <a:ext cx="2148840" cy="502920"/>
-          </a:xfrm>
-          <a:prstGeom prst="rect">
-            <a:avLst/>
-          </a:prstGeom>
-          <a:noFill/>
-        </p:spPr>
-        <p:txBody>
-          <a:bodyPr wrap="square" lIns="36576" rIns="36576" anchor="ctr">
-            <a:spAutoFit/>
-          </a:bodyPr>
-          <a:lstStyle/>
-          <a:p>
-            <a:pPr algn="ctr">
-              <a:defRPr sz="3000" b="1">
-                <a:solidFill>
-                  <a:srgbClr val="2A78D6"/>
-                </a:solidFill>
-                <a:latin typeface="Aptos"/>
-              </a:defRPr>
-            </a:pPr>
-            <a:r>
-              <a:t>1,090</a:t>
-            </a:r>
+          <p:cNvPr id="7" name="Rectangle 6"/>
+          <p:cNvSpPr/>
+          <p:nvPr/>
+        </p:nvSpPr>
+        <p:spPr>
+          <a:xfrm>
+            <a:off x="1005840" y="1417320"/>
+            <a:ext cx="146304" cy="822960"/>
+          </a:xfrm>
+          <a:prstGeom prst="rect">
+            <a:avLst/>
+          </a:prstGeom>
+          <a:solidFill>
+            <a:srgbClr val="D03B3B"/>
+          </a:solidFill>
+          <a:ln>
+            <a:noFill/>
+          </a:ln>
+        </p:spPr>
+        <p:style>
+          <a:lnRef idx="1">
+            <a:schemeClr val="accent1"/>
+          </a:lnRef>
+          <a:fillRef idx="3">
+            <a:schemeClr val="accent1"/>
+          </a:fillRef>
+          <a:effectRef idx="2">
+            <a:schemeClr val="accent1"/>
+          </a:effectRef>
+          <a:fontRef idx="minor">
+            <a:schemeClr val="lt1"/>
+          </a:fontRef>
+        </p:style>
+        <p:txBody>
+          <a:bodyPr rtlCol="0" anchor="ctr"/>
+          <a:lstStyle/>
+          <a:p>
+            <a:pPr algn="ctr"/>
           </a:p>
         </p:txBody>
       </p:sp>
@@ -9799,22 +10302,22 @@
         </p:nvSpPr>
         <p:spPr>
           <a:xfrm>
-            <a:off x="914400" y="2331720"/>
-            <a:ext cx="2148840" cy="256032"/>
-          </a:xfrm>
-          <a:prstGeom prst="rect">
-            <a:avLst/>
-          </a:prstGeom>
-          <a:noFill/>
-        </p:spPr>
-        <p:txBody>
-          <a:bodyPr wrap="square" lIns="36576" rIns="36576" anchor="ctr">
-            <a:spAutoFit/>
-          </a:bodyPr>
-          <a:lstStyle/>
-          <a:p>
-            <a:pPr algn="ctr">
-              <a:defRPr sz="1200" b="1">
+            <a:off x="1417320" y="1527048"/>
+            <a:ext cx="2194560" cy="274320"/>
+          </a:xfrm>
+          <a:prstGeom prst="rect">
+            <a:avLst/>
+          </a:prstGeom>
+          <a:noFill/>
+        </p:spPr>
+        <p:txBody>
+          <a:bodyPr wrap="square" lIns="36576" rIns="36576" anchor="ctr">
+            <a:spAutoFit/>
+          </a:bodyPr>
+          <a:lstStyle/>
+          <a:p>
+            <a:pPr algn="l">
+              <a:defRPr sz="1700" b="1">
                 <a:solidFill>
                   <a:srgbClr val="162B43"/>
                 </a:solidFill>
@@ -9822,21 +10325,57 @@
               </a:defRPr>
             </a:pPr>
             <a:r>
-              <a:t>simulated records</a:t>
-            </a:r>
-          </a:p>
-        </p:txBody>
-      </p:sp>
-      <p:sp>
-        <p:nvSpPr>
-          <p:cNvPr id="9" name="Rounded Rectangle 8"/>
+              <a:t>Executive</a:t>
+            </a:r>
+          </a:p>
+        </p:txBody>
+      </p:sp>
+      <p:sp>
+        <p:nvSpPr>
+          <p:cNvPr id="9" name="TextBox 8"/>
+          <p:cNvSpPr txBox="1"/>
+          <p:nvPr/>
+        </p:nvSpPr>
+        <p:spPr>
+          <a:xfrm>
+            <a:off x="3657600" y="1527048"/>
+            <a:ext cx="6949440" cy="274320"/>
+          </a:xfrm>
+          <a:prstGeom prst="rect">
+            <a:avLst/>
+          </a:prstGeom>
+          <a:noFill/>
+        </p:spPr>
+        <p:txBody>
+          <a:bodyPr wrap="square" lIns="36576" rIns="36576" anchor="ctr">
+            <a:spAutoFit/>
+          </a:bodyPr>
+          <a:lstStyle/>
+          <a:p>
+            <a:pPr algn="l">
+              <a:defRPr sz="1500" b="0">
+                <a:solidFill>
+                  <a:srgbClr val="212D3A"/>
+                </a:solidFill>
+                <a:latin typeface="Aptos"/>
+              </a:defRPr>
+            </a:pPr>
+            <a:r>
+              <a:t>Enterprise posture and key findings</a:t>
+            </a:r>
+          </a:p>
+        </p:txBody>
+      </p:sp>
+      <p:sp>
+        <p:nvSpPr>
+          <p:cNvPr id="10" name="Rounded Rectangle 9"/>
           <p:cNvSpPr/>
           <p:nvPr/>
         </p:nvSpPr>
         <p:spPr>
           <a:xfrm>
-            <a:off x="3611880" y="1508760"/>
-            <a:ext cx="2423160" cy="1508760"/>
+            <a:off x="1005840" y="2514600"/>
+            <a:ext cx="10149840" cy="822960"/>
           </a:xfrm>
           <a:prstGeom prst="roundRect">
             <a:avLst/>
@@ -9874,64 +10413,71 @@
       </p:sp>
       <p:sp>
         <p:nvSpPr>
-          <p:cNvPr id="10" name="TextBox 9"/>
-          <p:cNvSpPr txBox="1"/>
-          <p:nvPr/>
-        </p:nvSpPr>
-        <p:spPr>
-          <a:xfrm>
-            <a:off x="3749040" y="1719072"/>
-            <a:ext cx="2148840" cy="502920"/>
-          </a:xfrm>
-          <a:prstGeom prst="rect">
-            <a:avLst/>
-          </a:prstGeom>
-          <a:noFill/>
-        </p:spPr>
-        <p:txBody>
-          <a:bodyPr wrap="square" lIns="36576" rIns="36576" anchor="ctr">
-            <a:spAutoFit/>
-          </a:bodyPr>
-          <a:lstStyle/>
-          <a:p>
-            <a:pPr algn="ctr">
-              <a:defRPr sz="3000" b="1">
-                <a:solidFill>
-                  <a:srgbClr val="009196"/>
-                </a:solidFill>
-                <a:latin typeface="Aptos"/>
-              </a:defRPr>
-            </a:pPr>
-            <a:r>
-              <a:t>11</a:t>
-            </a:r>
-          </a:p>
-        </p:txBody>
-      </p:sp>
-      <p:sp>
-        <p:nvSpPr>
-          <p:cNvPr id="11" name="TextBox 10"/>
-          <p:cNvSpPr txBox="1"/>
-          <p:nvPr/>
-        </p:nvSpPr>
-        <p:spPr>
-          <a:xfrm>
-            <a:off x="3749040" y="2331720"/>
-            <a:ext cx="2148840" cy="256032"/>
-          </a:xfrm>
-          <a:prstGeom prst="rect">
-            <a:avLst/>
-          </a:prstGeom>
-          <a:noFill/>
-        </p:spPr>
-        <p:txBody>
-          <a:bodyPr wrap="square" lIns="36576" rIns="36576" anchor="ctr">
-            <a:spAutoFit/>
-          </a:bodyPr>
-          <a:lstStyle/>
-          <a:p>
-            <a:pPr algn="ctr">
-              <a:defRPr sz="1200" b="1">
+          <p:cNvPr id="11" name="Rectangle 10"/>
+          <p:cNvSpPr/>
+          <p:nvPr/>
+        </p:nvSpPr>
+        <p:spPr>
+          <a:xfrm>
+            <a:off x="1005840" y="2514600"/>
+            <a:ext cx="146304" cy="822960"/>
+          </a:xfrm>
+          <a:prstGeom prst="rect">
+            <a:avLst/>
+          </a:prstGeom>
+          <a:solidFill>
+            <a:srgbClr val="FAB219"/>
+          </a:solidFill>
+          <a:ln>
+            <a:noFill/>
+          </a:ln>
+        </p:spPr>
+        <p:style>
+          <a:lnRef idx="1">
+            <a:schemeClr val="accent1"/>
+          </a:lnRef>
+          <a:fillRef idx="3">
+            <a:schemeClr val="accent1"/>
+          </a:fillRef>
+          <a:effectRef idx="2">
+            <a:schemeClr val="accent1"/>
+          </a:effectRef>
+          <a:fontRef idx="minor">
+            <a:schemeClr val="lt1"/>
+          </a:fontRef>
+        </p:style>
+        <p:txBody>
+          <a:bodyPr rtlCol="0" anchor="ctr"/>
+          <a:lstStyle/>
+          <a:p>
+            <a:pPr algn="ctr"/>
+          </a:p>
+        </p:txBody>
+      </p:sp>
+      <p:sp>
+        <p:nvSpPr>
+          <p:cNvPr id="12" name="TextBox 11"/>
+          <p:cNvSpPr txBox="1"/>
+          <p:nvPr/>
+        </p:nvSpPr>
+        <p:spPr>
+          <a:xfrm>
+            <a:off x="1417320" y="2624328"/>
+            <a:ext cx="2194560" cy="274320"/>
+          </a:xfrm>
+          <a:prstGeom prst="rect">
+            <a:avLst/>
+          </a:prstGeom>
+          <a:noFill/>
+        </p:spPr>
+        <p:txBody>
+          <a:bodyPr wrap="square" lIns="36576" rIns="36576" anchor="ctr">
+            <a:spAutoFit/>
+          </a:bodyPr>
+          <a:lstStyle/>
+          <a:p>
+            <a:pPr algn="l">
+              <a:defRPr sz="1700" b="1">
                 <a:solidFill>
                   <a:srgbClr val="162B43"/>
                 </a:solidFill>
@@ -9939,21 +10485,57 @@
               </a:defRPr>
             </a:pPr>
             <a:r>
-              <a:t>data domains</a:t>
-            </a:r>
-          </a:p>
-        </p:txBody>
-      </p:sp>
-      <p:sp>
-        <p:nvSpPr>
-          <p:cNvPr id="12" name="Rounded Rectangle 11"/>
+              <a:t>Leadership</a:t>
+            </a:r>
+          </a:p>
+        </p:txBody>
+      </p:sp>
+      <p:sp>
+        <p:nvSpPr>
+          <p:cNvPr id="13" name="TextBox 12"/>
+          <p:cNvSpPr txBox="1"/>
+          <p:nvPr/>
+        </p:nvSpPr>
+        <p:spPr>
+          <a:xfrm>
+            <a:off x="3657600" y="2624328"/>
+            <a:ext cx="6949440" cy="274320"/>
+          </a:xfrm>
+          <a:prstGeom prst="rect">
+            <a:avLst/>
+          </a:prstGeom>
+          <a:noFill/>
+        </p:spPr>
+        <p:txBody>
+          <a:bodyPr wrap="square" lIns="36576" rIns="36576" anchor="ctr">
+            <a:spAutoFit/>
+          </a:bodyPr>
+          <a:lstStyle/>
+          <a:p>
+            <a:pPr algn="l">
+              <a:defRPr sz="1500" b="0">
+                <a:solidFill>
+                  <a:srgbClr val="212D3A"/>
+                </a:solidFill>
+                <a:latin typeface="Aptos"/>
+              </a:defRPr>
+            </a:pPr>
+            <a:r>
+              <a:t>Cross-domain compliance oversight</a:t>
+            </a:r>
+          </a:p>
+        </p:txBody>
+      </p:sp>
+      <p:sp>
+        <p:nvSpPr>
+          <p:cNvPr id="14" name="Rounded Rectangle 13"/>
           <p:cNvSpPr/>
           <p:nvPr/>
         </p:nvSpPr>
         <p:spPr>
           <a:xfrm>
-            <a:off x="6446520" y="1508760"/>
-            <a:ext cx="2423160" cy="1508760"/>
+            <a:off x="1005840" y="3611880"/>
+            <a:ext cx="10149840" cy="822960"/>
           </a:xfrm>
           <a:prstGeom prst="roundRect">
             <a:avLst/>
@@ -9991,64 +10573,71 @@
       </p:sp>
       <p:sp>
         <p:nvSpPr>
-          <p:cNvPr id="13" name="TextBox 12"/>
-          <p:cNvSpPr txBox="1"/>
-          <p:nvPr/>
-        </p:nvSpPr>
-        <p:spPr>
-          <a:xfrm>
-            <a:off x="6583680" y="1719072"/>
-            <a:ext cx="2148840" cy="502920"/>
-          </a:xfrm>
-          <a:prstGeom prst="rect">
-            <a:avLst/>
-          </a:prstGeom>
-          <a:noFill/>
-        </p:spPr>
-        <p:txBody>
-          <a:bodyPr wrap="square" lIns="36576" rIns="36576" anchor="ctr">
-            <a:spAutoFit/>
-          </a:bodyPr>
-          <a:lstStyle/>
-          <a:p>
-            <a:pPr algn="ctr">
-              <a:defRPr sz="3000" b="1">
-                <a:solidFill>
-                  <a:srgbClr val="0CA30C"/>
-                </a:solidFill>
-                <a:latin typeface="Aptos"/>
-              </a:defRPr>
-            </a:pPr>
-            <a:r>
-              <a:t>13</a:t>
-            </a:r>
-          </a:p>
-        </p:txBody>
-      </p:sp>
-      <p:sp>
-        <p:nvSpPr>
-          <p:cNvPr id="14" name="TextBox 13"/>
-          <p:cNvSpPr txBox="1"/>
-          <p:nvPr/>
-        </p:nvSpPr>
-        <p:spPr>
-          <a:xfrm>
-            <a:off x="6583680" y="2331720"/>
-            <a:ext cx="2148840" cy="256032"/>
-          </a:xfrm>
-          <a:prstGeom prst="rect">
-            <a:avLst/>
-          </a:prstGeom>
-          <a:noFill/>
-        </p:spPr>
-        <p:txBody>
-          <a:bodyPr wrap="square" lIns="36576" rIns="36576" anchor="ctr">
-            <a:spAutoFit/>
-          </a:bodyPr>
-          <a:lstStyle/>
-          <a:p>
-            <a:pPr algn="ctr">
-              <a:defRPr sz="1200" b="1">
+          <p:cNvPr id="15" name="Rectangle 14"/>
+          <p:cNvSpPr/>
+          <p:nvPr/>
+        </p:nvSpPr>
+        <p:spPr>
+          <a:xfrm>
+            <a:off x="1005840" y="3611880"/>
+            <a:ext cx="146304" cy="822960"/>
+          </a:xfrm>
+          <a:prstGeom prst="rect">
+            <a:avLst/>
+          </a:prstGeom>
+          <a:solidFill>
+            <a:srgbClr val="2A78D6"/>
+          </a:solidFill>
+          <a:ln>
+            <a:noFill/>
+          </a:ln>
+        </p:spPr>
+        <p:style>
+          <a:lnRef idx="1">
+            <a:schemeClr val="accent1"/>
+          </a:lnRef>
+          <a:fillRef idx="3">
+            <a:schemeClr val="accent1"/>
+          </a:fillRef>
+          <a:effectRef idx="2">
+            <a:schemeClr val="accent1"/>
+          </a:effectRef>
+          <a:fontRef idx="minor">
+            <a:schemeClr val="lt1"/>
+          </a:fontRef>
+        </p:style>
+        <p:txBody>
+          <a:bodyPr rtlCol="0" anchor="ctr"/>
+          <a:lstStyle/>
+          <a:p>
+            <a:pPr algn="ctr"/>
+          </a:p>
+        </p:txBody>
+      </p:sp>
+      <p:sp>
+        <p:nvSpPr>
+          <p:cNvPr id="16" name="TextBox 15"/>
+          <p:cNvSpPr txBox="1"/>
+          <p:nvPr/>
+        </p:nvSpPr>
+        <p:spPr>
+          <a:xfrm>
+            <a:off x="1417320" y="3721608"/>
+            <a:ext cx="2194560" cy="274320"/>
+          </a:xfrm>
+          <a:prstGeom prst="rect">
+            <a:avLst/>
+          </a:prstGeom>
+          <a:noFill/>
+        </p:spPr>
+        <p:txBody>
+          <a:bodyPr wrap="square" lIns="36576" rIns="36576" anchor="ctr">
+            <a:spAutoFit/>
+          </a:bodyPr>
+          <a:lstStyle/>
+          <a:p>
+            <a:pPr algn="l">
+              <a:defRPr sz="1700" b="1">
                 <a:solidFill>
                   <a:srgbClr val="162B43"/>
                 </a:solidFill>
@@ -10056,21 +10645,57 @@
               </a:defRPr>
             </a:pPr>
             <a:r>
-              <a:t>dashboard pages</a:t>
-            </a:r>
-          </a:p>
-        </p:txBody>
-      </p:sp>
-      <p:sp>
-        <p:nvSpPr>
-          <p:cNvPr id="15" name="Rounded Rectangle 14"/>
+              <a:t>Operations</a:t>
+            </a:r>
+          </a:p>
+        </p:txBody>
+      </p:sp>
+      <p:sp>
+        <p:nvSpPr>
+          <p:cNvPr id="17" name="TextBox 16"/>
+          <p:cNvSpPr txBox="1"/>
+          <p:nvPr/>
+        </p:nvSpPr>
+        <p:spPr>
+          <a:xfrm>
+            <a:off x="3657600" y="3721608"/>
+            <a:ext cx="6949440" cy="274320"/>
+          </a:xfrm>
+          <a:prstGeom prst="rect">
+            <a:avLst/>
+          </a:prstGeom>
+          <a:noFill/>
+        </p:spPr>
+        <p:txBody>
+          <a:bodyPr wrap="square" lIns="36576" rIns="36576" anchor="ctr">
+            <a:spAutoFit/>
+          </a:bodyPr>
+          <a:lstStyle/>
+          <a:p>
+            <a:pPr algn="l">
+              <a:defRPr sz="1500" b="0">
+                <a:solidFill>
+                  <a:srgbClr val="212D3A"/>
+                </a:solidFill>
+                <a:latin typeface="Aptos"/>
+              </a:defRPr>
+            </a:pPr>
+            <a:r>
+              <a:t>Detailed records and remediation</a:t>
+            </a:r>
+          </a:p>
+        </p:txBody>
+      </p:sp>
+      <p:sp>
+        <p:nvSpPr>
+          <p:cNvPr id="18" name="Rounded Rectangle 17"/>
           <p:cNvSpPr/>
           <p:nvPr/>
         </p:nvSpPr>
         <p:spPr>
           <a:xfrm>
-            <a:off x="9281160" y="1508760"/>
-            <a:ext cx="2423160" cy="1508760"/>
+            <a:off x="1005840" y="4709159"/>
+            <a:ext cx="10149840" cy="822960"/>
           </a:xfrm>
           <a:prstGeom prst="roundRect">
             <a:avLst/>
@@ -10108,131 +10733,14 @@
       </p:sp>
       <p:sp>
         <p:nvSpPr>
-          <p:cNvPr id="16" name="TextBox 15"/>
-          <p:cNvSpPr txBox="1"/>
-          <p:nvPr/>
-        </p:nvSpPr>
-        <p:spPr>
-          <a:xfrm>
-            <a:off x="9418320" y="1719072"/>
-            <a:ext cx="2148840" cy="502920"/>
-          </a:xfrm>
-          <a:prstGeom prst="rect">
-            <a:avLst/>
-          </a:prstGeom>
-          <a:noFill/>
-        </p:spPr>
-        <p:txBody>
-          <a:bodyPr wrap="square" lIns="36576" rIns="36576" anchor="ctr">
-            <a:spAutoFit/>
-          </a:bodyPr>
-          <a:lstStyle/>
-          <a:p>
-            <a:pPr algn="ctr">
-              <a:defRPr sz="3000" b="1">
-                <a:solidFill>
-                  <a:srgbClr val="FAB219"/>
-                </a:solidFill>
-                <a:latin typeface="Aptos"/>
-              </a:defRPr>
-            </a:pPr>
-            <a:r>
-              <a:t>4</a:t>
-            </a:r>
-          </a:p>
-        </p:txBody>
-      </p:sp>
-      <p:sp>
-        <p:nvSpPr>
-          <p:cNvPr id="17" name="TextBox 16"/>
-          <p:cNvSpPr txBox="1"/>
-          <p:nvPr/>
-        </p:nvSpPr>
-        <p:spPr>
-          <a:xfrm>
-            <a:off x="9418320" y="2331720"/>
-            <a:ext cx="2148840" cy="256032"/>
-          </a:xfrm>
-          <a:prstGeom prst="rect">
-            <a:avLst/>
-          </a:prstGeom>
-          <a:noFill/>
-        </p:spPr>
-        <p:txBody>
-          <a:bodyPr wrap="square" lIns="36576" rIns="36576" anchor="ctr">
-            <a:spAutoFit/>
-          </a:bodyPr>
-          <a:lstStyle/>
-          <a:p>
-            <a:pPr algn="ctr">
-              <a:defRPr sz="1200" b="1">
-                <a:solidFill>
-                  <a:srgbClr val="162B43"/>
-                </a:solidFill>
-                <a:latin typeface="Aptos"/>
-              </a:defRPr>
-            </a:pPr>
-            <a:r>
-              <a:t>user roles</a:t>
-            </a:r>
-          </a:p>
-        </p:txBody>
-      </p:sp>
-      <p:sp>
-        <p:nvSpPr>
-          <p:cNvPr id="18" name="Rounded Rectangle 17"/>
-          <p:cNvSpPr/>
-          <p:nvPr/>
-        </p:nvSpPr>
-        <p:spPr>
-          <a:xfrm>
-            <a:off x="960120" y="3657600"/>
-            <a:ext cx="4800600" cy="1417320"/>
-          </a:xfrm>
-          <a:prstGeom prst="roundRect">
-            <a:avLst/>
-          </a:prstGeom>
-          <a:solidFill>
-            <a:srgbClr val="F3F7F8"/>
-          </a:solidFill>
-          <a:ln>
-            <a:solidFill>
-              <a:srgbClr val="DCE5E8"/>
-            </a:solidFill>
-          </a:ln>
-        </p:spPr>
-        <p:style>
-          <a:lnRef idx="1">
-            <a:schemeClr val="accent1"/>
-          </a:lnRef>
-          <a:fillRef idx="3">
-            <a:schemeClr val="accent1"/>
-          </a:fillRef>
-          <a:effectRef idx="2">
-            <a:schemeClr val="accent1"/>
-          </a:effectRef>
-          <a:fontRef idx="minor">
-            <a:schemeClr val="lt1"/>
-          </a:fontRef>
-        </p:style>
-        <p:txBody>
-          <a:bodyPr rtlCol="0" anchor="ctr"/>
-          <a:lstStyle/>
-          <a:p>
-            <a:pPr algn="ctr"/>
-          </a:p>
-        </p:txBody>
-      </p:sp>
-      <p:sp>
-        <p:nvSpPr>
           <p:cNvPr id="19" name="Rectangle 18"/>
           <p:cNvSpPr/>
           <p:nvPr/>
         </p:nvSpPr>
         <p:spPr>
           <a:xfrm>
-            <a:off x="960120" y="3657600"/>
-            <a:ext cx="73152" cy="1417320"/>
+            <a:off x="1005840" y="4709159"/>
+            <a:ext cx="146304" cy="822960"/>
           </a:xfrm>
           <a:prstGeom prst="rect">
             <a:avLst/>
@@ -10274,8 +10782,8 @@
         </p:nvSpPr>
         <p:spPr>
           <a:xfrm>
-            <a:off x="1188720" y="3803904"/>
-            <a:ext cx="4389120" cy="310896"/>
+            <a:off x="1417320" y="4818888"/>
+            <a:ext cx="2194560" cy="274320"/>
           </a:xfrm>
           <a:prstGeom prst="rect">
             <a:avLst/>
@@ -10289,7 +10797,7 @@
           <a:lstStyle/>
           <a:p>
             <a:pPr algn="l">
-              <a:defRPr sz="1500" b="1">
+              <a:defRPr sz="1700" b="1">
                 <a:solidFill>
                   <a:srgbClr val="162B43"/>
                 </a:solidFill>
@@ -10297,7 +10805,7 @@
               </a:defRPr>
             </a:pPr>
             <a:r>
-              <a:t>Compliance posture</a:t>
+              <a:t>Admin</a:t>
             </a:r>
           </a:p>
         </p:txBody>
@@ -10310,8 +10818,8 @@
         </p:nvSpPr>
         <p:spPr>
           <a:xfrm>
-            <a:off x="1188720" y="4187952"/>
-            <a:ext cx="4389120" cy="758952"/>
+            <a:off x="3657600" y="4818888"/>
+            <a:ext cx="6949440" cy="274320"/>
           </a:xfrm>
           <a:prstGeom prst="rect">
             <a:avLst/>
@@ -10325,7 +10833,7 @@
           <a:lstStyle/>
           <a:p>
             <a:pPr algn="l">
-              <a:defRPr sz="1300" b="0">
+              <a:defRPr sz="1500" b="0">
                 <a:solidFill>
                   <a:srgbClr val="212D3A"/>
                 </a:solidFill>
@@ -10333,174 +10841,50 @@
               </a:defRPr>
             </a:pPr>
             <a:r>
-              <a:t>Overall compliance, non-compliant records, exceptions, and not-assessed populations.</a:t>
-            </a:r>
-          </a:p>
-        </p:txBody>
-      </p:sp>
-      <p:sp>
-        <p:nvSpPr>
-          <p:cNvPr id="22" name="Rounded Rectangle 21"/>
-          <p:cNvSpPr/>
-          <p:nvPr/>
-        </p:nvSpPr>
-        <p:spPr>
-          <a:xfrm>
-            <a:off x="6400800" y="3657600"/>
-            <a:ext cx="4800600" cy="1417320"/>
-          </a:xfrm>
-          <a:prstGeom prst="roundRect">
-            <a:avLst/>
-          </a:prstGeom>
-          <a:solidFill>
-            <a:srgbClr val="F3F7F8"/>
-          </a:solidFill>
-          <a:ln>
-            <a:solidFill>
-              <a:srgbClr val="DCE5E8"/>
-            </a:solidFill>
-          </a:ln>
-        </p:spPr>
-        <p:style>
-          <a:lnRef idx="1">
-            <a:schemeClr val="accent1"/>
-          </a:lnRef>
-          <a:fillRef idx="3">
-            <a:schemeClr val="accent1"/>
-          </a:fillRef>
-          <a:effectRef idx="2">
-            <a:schemeClr val="accent1"/>
-          </a:effectRef>
-          <a:fontRef idx="minor">
-            <a:schemeClr val="lt1"/>
-          </a:fontRef>
-        </p:style>
-        <p:txBody>
-          <a:bodyPr rtlCol="0" anchor="ctr"/>
-          <a:lstStyle/>
-          <a:p>
-            <a:pPr algn="ctr"/>
-          </a:p>
-        </p:txBody>
-      </p:sp>
-      <p:sp>
-        <p:nvSpPr>
-          <p:cNvPr id="23" name="Rectangle 22"/>
-          <p:cNvSpPr/>
-          <p:nvPr/>
-        </p:nvSpPr>
-        <p:spPr>
-          <a:xfrm>
-            <a:off x="6400800" y="3657600"/>
-            <a:ext cx="73152" cy="1417320"/>
-          </a:xfrm>
-          <a:prstGeom prst="rect">
-            <a:avLst/>
-          </a:prstGeom>
-          <a:solidFill>
-            <a:srgbClr val="2A78D6"/>
-          </a:solidFill>
-          <a:ln>
-            <a:noFill/>
-          </a:ln>
-        </p:spPr>
-        <p:style>
-          <a:lnRef idx="1">
-            <a:schemeClr val="accent1"/>
-          </a:lnRef>
-          <a:fillRef idx="3">
-            <a:schemeClr val="accent1"/>
-          </a:fillRef>
-          <a:effectRef idx="2">
-            <a:schemeClr val="accent1"/>
-          </a:effectRef>
-          <a:fontRef idx="minor">
-            <a:schemeClr val="lt1"/>
-          </a:fontRef>
-        </p:style>
-        <p:txBody>
-          <a:bodyPr rtlCol="0" anchor="ctr"/>
-          <a:lstStyle/>
-          <a:p>
-            <a:pPr algn="ctr"/>
-          </a:p>
-        </p:txBody>
-      </p:sp>
-      <p:sp>
-        <p:nvSpPr>
-          <p:cNvPr id="24" name="TextBox 23"/>
-          <p:cNvSpPr txBox="1"/>
-          <p:nvPr/>
-        </p:nvSpPr>
-        <p:spPr>
-          <a:xfrm>
-            <a:off x="6629400" y="3803904"/>
-            <a:ext cx="4389120" cy="310896"/>
-          </a:xfrm>
-          <a:prstGeom prst="rect">
-            <a:avLst/>
-          </a:prstGeom>
-          <a:noFill/>
-        </p:spPr>
-        <p:txBody>
-          <a:bodyPr wrap="square" lIns="36576" rIns="36576" anchor="ctr">
-            <a:spAutoFit/>
-          </a:bodyPr>
-          <a:lstStyle/>
-          <a:p>
-            <a:pPr algn="l">
-              <a:defRPr sz="1500" b="1">
-                <a:solidFill>
-                  <a:srgbClr val="162B43"/>
-                </a:solidFill>
-                <a:latin typeface="Aptos"/>
-              </a:defRPr>
-            </a:pPr>
-            <a:r>
-              <a:t>Control posture</a:t>
-            </a:r>
-          </a:p>
-        </p:txBody>
-      </p:sp>
-      <p:sp>
-        <p:nvSpPr>
-          <p:cNvPr id="25" name="TextBox 24"/>
-          <p:cNvSpPr txBox="1"/>
-          <p:nvPr/>
-        </p:nvSpPr>
-        <p:spPr>
-          <a:xfrm>
-            <a:off x="6629400" y="4187952"/>
-            <a:ext cx="4389120" cy="758952"/>
-          </a:xfrm>
-          <a:prstGeom prst="rect">
-            <a:avLst/>
-          </a:prstGeom>
-          <a:noFill/>
-        </p:spPr>
-        <p:txBody>
-          <a:bodyPr wrap="square" lIns="36576" rIns="36576" anchor="ctr">
-            <a:spAutoFit/>
-          </a:bodyPr>
-          <a:lstStyle/>
-          <a:p>
-            <a:pPr algn="l">
-              <a:defRPr sz="1300" b="0">
-                <a:solidFill>
-                  <a:srgbClr val="212D3A"/>
-                </a:solidFill>
-                <a:latin typeface="Aptos"/>
-              </a:defRPr>
-            </a:pPr>
-            <a:r>
-              <a:t>PAM onboarding, password management, authentication integration, and risk ratings.</a:t>
-            </a:r>
-          </a:p>
-        </p:txBody>
-      </p:sp>
-      <p:sp>
-        <p:nvSpPr>
-          <p:cNvPr id="26" name="TextBox 25"/>
+              <a:t>Field visibility and user registry</a:t>
+            </a:r>
+          </a:p>
+        </p:txBody>
+      </p:sp>
+      <p:sp>
+        <p:nvSpPr>
+          <p:cNvPr id="22" name="TextBox 21"/>
+          <p:cNvSpPr txBox="1"/>
+          <p:nvPr/>
+        </p:nvSpPr>
+        <p:spPr>
+          <a:xfrm>
+            <a:off x="1005840" y="5715000"/>
+            <a:ext cx="10058400" cy="320040"/>
+          </a:xfrm>
+          <a:prstGeom prst="rect">
+            <a:avLst/>
+          </a:prstGeom>
+          <a:noFill/>
+        </p:spPr>
+        <p:txBody>
+          <a:bodyPr wrap="square" lIns="36576" rIns="36576" anchor="ctr">
+            <a:spAutoFit/>
+          </a:bodyPr>
+          <a:lstStyle/>
+          <a:p>
+            <a:pPr algn="ctr">
+              <a:defRPr sz="1500" b="0">
+                <a:solidFill>
+                  <a:srgbClr val="5D6C7B"/>
+                </a:solidFill>
+                <a:latin typeface="Aptos"/>
+              </a:defRPr>
+            </a:pPr>
+            <a:r>
+              <a:t>Visibility is tailored by role; production authorization should be enforced server-side as well.</a:t>
+            </a:r>
+          </a:p>
+        </p:txBody>
+      </p:sp>
+      <p:sp>
+        <p:nvSpPr>
+          <p:cNvPr id="23" name="TextBox 22"/>
           <p:cNvSpPr txBox="1"/>
           <p:nvPr/>
         </p:nvSpPr>
@@ -10536,7 +10920,7 @@
       </p:sp>
       <p:sp>
         <p:nvSpPr>
-          <p:cNvPr id="27" name="TextBox 26"/>
+          <p:cNvPr id="24" name="TextBox 23"/>
           <p:cNvSpPr txBox="1"/>
           <p:nvPr/>
         </p:nvSpPr>
@@ -10662,7 +11046,7 @@
               </a:defRPr>
             </a:pPr>
             <a:r>
-              <a:t>Deployment model</a:t>
+              <a:t>Executive view and metrics</a:t>
             </a:r>
           </a:p>
         </p:txBody>
@@ -10698,7 +11082,7 @@
               </a:defRPr>
             </a:pPr>
             <a:r>
-              <a:t>HOW TO SHARE THE DEMO</a:t>
+              <a:t>DECISION SUPPORT</a:t>
             </a:r>
           </a:p>
         </p:txBody>
@@ -10754,8 +11138,8 @@
         </p:nvSpPr>
         <p:spPr>
           <a:xfrm>
-            <a:off x="731520" y="1417320"/>
-            <a:ext cx="3337560" cy="3429000"/>
+            <a:off x="777240" y="1508760"/>
+            <a:ext cx="2423160" cy="1508760"/>
           </a:xfrm>
           <a:prstGeom prst="roundRect">
             <a:avLst/>
@@ -10793,139 +11177,86 @@
       </p:sp>
       <p:sp>
         <p:nvSpPr>
-          <p:cNvPr id="7" name="Rectangle 6"/>
+          <p:cNvPr id="7" name="TextBox 6"/>
+          <p:cNvSpPr txBox="1"/>
+          <p:nvPr/>
+        </p:nvSpPr>
+        <p:spPr>
+          <a:xfrm>
+            <a:off x="914400" y="1719072"/>
+            <a:ext cx="2148840" cy="502920"/>
+          </a:xfrm>
+          <a:prstGeom prst="rect">
+            <a:avLst/>
+          </a:prstGeom>
+          <a:noFill/>
+        </p:spPr>
+        <p:txBody>
+          <a:bodyPr wrap="square" lIns="36576" rIns="36576" anchor="ctr">
+            <a:spAutoFit/>
+          </a:bodyPr>
+          <a:lstStyle/>
+          <a:p>
+            <a:pPr algn="ctr">
+              <a:defRPr sz="3000" b="1">
+                <a:solidFill>
+                  <a:srgbClr val="2A78D6"/>
+                </a:solidFill>
+                <a:latin typeface="Aptos"/>
+              </a:defRPr>
+            </a:pPr>
+            <a:r>
+              <a:t>1,090</a:t>
+            </a:r>
+          </a:p>
+        </p:txBody>
+      </p:sp>
+      <p:sp>
+        <p:nvSpPr>
+          <p:cNvPr id="8" name="TextBox 7"/>
+          <p:cNvSpPr txBox="1"/>
+          <p:nvPr/>
+        </p:nvSpPr>
+        <p:spPr>
+          <a:xfrm>
+            <a:off x="914400" y="2331720"/>
+            <a:ext cx="2148840" cy="256032"/>
+          </a:xfrm>
+          <a:prstGeom prst="rect">
+            <a:avLst/>
+          </a:prstGeom>
+          <a:noFill/>
+        </p:spPr>
+        <p:txBody>
+          <a:bodyPr wrap="square" lIns="36576" rIns="36576" anchor="ctr">
+            <a:spAutoFit/>
+          </a:bodyPr>
+          <a:lstStyle/>
+          <a:p>
+            <a:pPr algn="ctr">
+              <a:defRPr sz="1200" b="1">
+                <a:solidFill>
+                  <a:srgbClr val="162B43"/>
+                </a:solidFill>
+                <a:latin typeface="Aptos"/>
+              </a:defRPr>
+            </a:pPr>
+            <a:r>
+              <a:t>simulated records</a:t>
+            </a:r>
+          </a:p>
+        </p:txBody>
+      </p:sp>
+      <p:sp>
+        <p:nvSpPr>
+          <p:cNvPr id="9" name="Rounded Rectangle 8"/>
           <p:cNvSpPr/>
           <p:nvPr/>
         </p:nvSpPr>
         <p:spPr>
           <a:xfrm>
-            <a:off x="731520" y="1417320"/>
-            <a:ext cx="73152" cy="3429000"/>
-          </a:xfrm>
-          <a:prstGeom prst="rect">
-            <a:avLst/>
-          </a:prstGeom>
-          <a:solidFill>
-            <a:srgbClr val="162B43"/>
-          </a:solidFill>
-          <a:ln>
-            <a:noFill/>
-          </a:ln>
-        </p:spPr>
-        <p:style>
-          <a:lnRef idx="1">
-            <a:schemeClr val="accent1"/>
-          </a:lnRef>
-          <a:fillRef idx="3">
-            <a:schemeClr val="accent1"/>
-          </a:fillRef>
-          <a:effectRef idx="2">
-            <a:schemeClr val="accent1"/>
-          </a:effectRef>
-          <a:fontRef idx="minor">
-            <a:schemeClr val="lt1"/>
-          </a:fontRef>
-        </p:style>
-        <p:txBody>
-          <a:bodyPr rtlCol="0" anchor="ctr"/>
-          <a:lstStyle/>
-          <a:p>
-            <a:pPr algn="ctr"/>
-          </a:p>
-        </p:txBody>
-      </p:sp>
-      <p:sp>
-        <p:nvSpPr>
-          <p:cNvPr id="8" name="TextBox 7"/>
-          <p:cNvSpPr txBox="1"/>
-          <p:nvPr/>
-        </p:nvSpPr>
-        <p:spPr>
-          <a:xfrm>
-            <a:off x="960120" y="1563624"/>
-            <a:ext cx="2926079" cy="310896"/>
-          </a:xfrm>
-          <a:prstGeom prst="rect">
-            <a:avLst/>
-          </a:prstGeom>
-          <a:noFill/>
-        </p:spPr>
-        <p:txBody>
-          <a:bodyPr wrap="square" lIns="36576" rIns="36576" anchor="ctr">
-            <a:spAutoFit/>
-          </a:bodyPr>
-          <a:lstStyle/>
-          <a:p>
-            <a:pPr algn="l">
-              <a:defRPr sz="1500" b="1">
-                <a:solidFill>
-                  <a:srgbClr val="162B43"/>
-                </a:solidFill>
-                <a:latin typeface="Aptos"/>
-              </a:defRPr>
-            </a:pPr>
-            <a:r>
-              <a:t>Source</a:t>
-            </a:r>
-          </a:p>
-        </p:txBody>
-      </p:sp>
-      <p:sp>
-        <p:nvSpPr>
-          <p:cNvPr id="9" name="TextBox 8"/>
-          <p:cNvSpPr txBox="1"/>
-          <p:nvPr/>
-        </p:nvSpPr>
-        <p:spPr>
-          <a:xfrm>
-            <a:off x="960120" y="1947672"/>
-            <a:ext cx="2926079" cy="2770632"/>
-          </a:xfrm>
-          <a:prstGeom prst="rect">
-            <a:avLst/>
-          </a:prstGeom>
-          <a:noFill/>
-        </p:spPr>
-        <p:txBody>
-          <a:bodyPr wrap="square" lIns="36576" rIns="36576" anchor="ctr">
-            <a:spAutoFit/>
-          </a:bodyPr>
-          <a:lstStyle/>
-          <a:p>
-            <a:pPr algn="l">
-              <a:defRPr sz="1400" b="0">
-                <a:solidFill>
-                  <a:srgbClr val="212D3A"/>
-                </a:solidFill>
-                <a:latin typeface="Aptos"/>
-              </a:defRPr>
-            </a:pPr>
-            <a:r>
-              <a:t>GitHub repository</a:t>
-            </a:r>
-            <a:br/>
-            <a:br/>
-            <a:r>
-              <a:t>2025aa05980/compliance-dashboard</a:t>
-            </a:r>
-            <a:br/>
-            <a:br/>
-            <a:r>
-              <a:t>Versioned source, requirements, data, and Render configuration.</a:t>
-            </a:r>
-          </a:p>
-        </p:txBody>
-      </p:sp>
-      <p:sp>
-        <p:nvSpPr>
-          <p:cNvPr id="10" name="Rounded Rectangle 9"/>
-          <p:cNvSpPr/>
-          <p:nvPr/>
-        </p:nvSpPr>
-        <p:spPr>
-          <a:xfrm>
-            <a:off x="4434840" y="1417320"/>
-            <a:ext cx="3337560" cy="3429000"/>
+            <a:off x="3611880" y="1508760"/>
+            <a:ext cx="2423160" cy="1508760"/>
           </a:xfrm>
           <a:prstGeom prst="roundRect">
             <a:avLst/>
@@ -10963,139 +11294,86 @@
       </p:sp>
       <p:sp>
         <p:nvSpPr>
-          <p:cNvPr id="11" name="Rectangle 10"/>
+          <p:cNvPr id="10" name="TextBox 9"/>
+          <p:cNvSpPr txBox="1"/>
+          <p:nvPr/>
+        </p:nvSpPr>
+        <p:spPr>
+          <a:xfrm>
+            <a:off x="3749040" y="1719072"/>
+            <a:ext cx="2148840" cy="502920"/>
+          </a:xfrm>
+          <a:prstGeom prst="rect">
+            <a:avLst/>
+          </a:prstGeom>
+          <a:noFill/>
+        </p:spPr>
+        <p:txBody>
+          <a:bodyPr wrap="square" lIns="36576" rIns="36576" anchor="ctr">
+            <a:spAutoFit/>
+          </a:bodyPr>
+          <a:lstStyle/>
+          <a:p>
+            <a:pPr algn="ctr">
+              <a:defRPr sz="3000" b="1">
+                <a:solidFill>
+                  <a:srgbClr val="009196"/>
+                </a:solidFill>
+                <a:latin typeface="Aptos"/>
+              </a:defRPr>
+            </a:pPr>
+            <a:r>
+              <a:t>11</a:t>
+            </a:r>
+          </a:p>
+        </p:txBody>
+      </p:sp>
+      <p:sp>
+        <p:nvSpPr>
+          <p:cNvPr id="11" name="TextBox 10"/>
+          <p:cNvSpPr txBox="1"/>
+          <p:nvPr/>
+        </p:nvSpPr>
+        <p:spPr>
+          <a:xfrm>
+            <a:off x="3749040" y="2331720"/>
+            <a:ext cx="2148840" cy="256032"/>
+          </a:xfrm>
+          <a:prstGeom prst="rect">
+            <a:avLst/>
+          </a:prstGeom>
+          <a:noFill/>
+        </p:spPr>
+        <p:txBody>
+          <a:bodyPr wrap="square" lIns="36576" rIns="36576" anchor="ctr">
+            <a:spAutoFit/>
+          </a:bodyPr>
+          <a:lstStyle/>
+          <a:p>
+            <a:pPr algn="ctr">
+              <a:defRPr sz="1200" b="1">
+                <a:solidFill>
+                  <a:srgbClr val="162B43"/>
+                </a:solidFill>
+                <a:latin typeface="Aptos"/>
+              </a:defRPr>
+            </a:pPr>
+            <a:r>
+              <a:t>data domains</a:t>
+            </a:r>
+          </a:p>
+        </p:txBody>
+      </p:sp>
+      <p:sp>
+        <p:nvSpPr>
+          <p:cNvPr id="12" name="Rounded Rectangle 11"/>
           <p:cNvSpPr/>
           <p:nvPr/>
         </p:nvSpPr>
         <p:spPr>
           <a:xfrm>
-            <a:off x="4434840" y="1417320"/>
-            <a:ext cx="73152" cy="3429000"/>
-          </a:xfrm>
-          <a:prstGeom prst="rect">
-            <a:avLst/>
-          </a:prstGeom>
-          <a:solidFill>
-            <a:srgbClr val="009196"/>
-          </a:solidFill>
-          <a:ln>
-            <a:noFill/>
-          </a:ln>
-        </p:spPr>
-        <p:style>
-          <a:lnRef idx="1">
-            <a:schemeClr val="accent1"/>
-          </a:lnRef>
-          <a:fillRef idx="3">
-            <a:schemeClr val="accent1"/>
-          </a:fillRef>
-          <a:effectRef idx="2">
-            <a:schemeClr val="accent1"/>
-          </a:effectRef>
-          <a:fontRef idx="minor">
-            <a:schemeClr val="lt1"/>
-          </a:fontRef>
-        </p:style>
-        <p:txBody>
-          <a:bodyPr rtlCol="0" anchor="ctr"/>
-          <a:lstStyle/>
-          <a:p>
-            <a:pPr algn="ctr"/>
-          </a:p>
-        </p:txBody>
-      </p:sp>
-      <p:sp>
-        <p:nvSpPr>
-          <p:cNvPr id="12" name="TextBox 11"/>
-          <p:cNvSpPr txBox="1"/>
-          <p:nvPr/>
-        </p:nvSpPr>
-        <p:spPr>
-          <a:xfrm>
-            <a:off x="4663440" y="1563624"/>
-            <a:ext cx="2926079" cy="310896"/>
-          </a:xfrm>
-          <a:prstGeom prst="rect">
-            <a:avLst/>
-          </a:prstGeom>
-          <a:noFill/>
-        </p:spPr>
-        <p:txBody>
-          <a:bodyPr wrap="square" lIns="36576" rIns="36576" anchor="ctr">
-            <a:spAutoFit/>
-          </a:bodyPr>
-          <a:lstStyle/>
-          <a:p>
-            <a:pPr algn="l">
-              <a:defRPr sz="1500" b="1">
-                <a:solidFill>
-                  <a:srgbClr val="162B43"/>
-                </a:solidFill>
-                <a:latin typeface="Aptos"/>
-              </a:defRPr>
-            </a:pPr>
-            <a:r>
-              <a:t>Build</a:t>
-            </a:r>
-          </a:p>
-        </p:txBody>
-      </p:sp>
-      <p:sp>
-        <p:nvSpPr>
-          <p:cNvPr id="13" name="TextBox 12"/>
-          <p:cNvSpPr txBox="1"/>
-          <p:nvPr/>
-        </p:nvSpPr>
-        <p:spPr>
-          <a:xfrm>
-            <a:off x="4663440" y="1947672"/>
-            <a:ext cx="2926079" cy="2770632"/>
-          </a:xfrm>
-          <a:prstGeom prst="rect">
-            <a:avLst/>
-          </a:prstGeom>
-          <a:noFill/>
-        </p:spPr>
-        <p:txBody>
-          <a:bodyPr wrap="square" lIns="36576" rIns="36576" anchor="ctr">
-            <a:spAutoFit/>
-          </a:bodyPr>
-          <a:lstStyle/>
-          <a:p>
-            <a:pPr algn="l">
-              <a:defRPr sz="1400" b="0">
-                <a:solidFill>
-                  <a:srgbClr val="212D3A"/>
-                </a:solidFill>
-                <a:latin typeface="Aptos"/>
-              </a:defRPr>
-            </a:pPr>
-            <a:r>
-              <a:t>Render installs requirements.txt and runs:</a:t>
-            </a:r>
-            <a:br/>
-            <a:br/>
-            <a:r>
-              <a:t>Gunicorn app:server</a:t>
-            </a:r>
-            <a:br/>
-            <a:br/>
-            <a:r>
-              <a:t>The Dash WSGI server is exposed over HTTPS.</a:t>
-            </a:r>
-          </a:p>
-        </p:txBody>
-      </p:sp>
-      <p:sp>
-        <p:nvSpPr>
-          <p:cNvPr id="14" name="Rounded Rectangle 13"/>
-          <p:cNvSpPr/>
-          <p:nvPr/>
-        </p:nvSpPr>
-        <p:spPr>
-          <a:xfrm>
-            <a:off x="8138160" y="1417320"/>
-            <a:ext cx="3337560" cy="3429000"/>
+            <a:off x="6446520" y="1508760"/>
+            <a:ext cx="2423160" cy="1508760"/>
           </a:xfrm>
           <a:prstGeom prst="roundRect">
             <a:avLst/>
@@ -11133,14 +11411,408 @@
       </p:sp>
       <p:sp>
         <p:nvSpPr>
-          <p:cNvPr id="15" name="Rectangle 14"/>
+          <p:cNvPr id="13" name="TextBox 12"/>
+          <p:cNvSpPr txBox="1"/>
+          <p:nvPr/>
+        </p:nvSpPr>
+        <p:spPr>
+          <a:xfrm>
+            <a:off x="6583680" y="1719072"/>
+            <a:ext cx="2148840" cy="502920"/>
+          </a:xfrm>
+          <a:prstGeom prst="rect">
+            <a:avLst/>
+          </a:prstGeom>
+          <a:noFill/>
+        </p:spPr>
+        <p:txBody>
+          <a:bodyPr wrap="square" lIns="36576" rIns="36576" anchor="ctr">
+            <a:spAutoFit/>
+          </a:bodyPr>
+          <a:lstStyle/>
+          <a:p>
+            <a:pPr algn="ctr">
+              <a:defRPr sz="3000" b="1">
+                <a:solidFill>
+                  <a:srgbClr val="0CA30C"/>
+                </a:solidFill>
+                <a:latin typeface="Aptos"/>
+              </a:defRPr>
+            </a:pPr>
+            <a:r>
+              <a:t>13</a:t>
+            </a:r>
+          </a:p>
+        </p:txBody>
+      </p:sp>
+      <p:sp>
+        <p:nvSpPr>
+          <p:cNvPr id="14" name="TextBox 13"/>
+          <p:cNvSpPr txBox="1"/>
+          <p:nvPr/>
+        </p:nvSpPr>
+        <p:spPr>
+          <a:xfrm>
+            <a:off x="6583680" y="2331720"/>
+            <a:ext cx="2148840" cy="256032"/>
+          </a:xfrm>
+          <a:prstGeom prst="rect">
+            <a:avLst/>
+          </a:prstGeom>
+          <a:noFill/>
+        </p:spPr>
+        <p:txBody>
+          <a:bodyPr wrap="square" lIns="36576" rIns="36576" anchor="ctr">
+            <a:spAutoFit/>
+          </a:bodyPr>
+          <a:lstStyle/>
+          <a:p>
+            <a:pPr algn="ctr">
+              <a:defRPr sz="1200" b="1">
+                <a:solidFill>
+                  <a:srgbClr val="162B43"/>
+                </a:solidFill>
+                <a:latin typeface="Aptos"/>
+              </a:defRPr>
+            </a:pPr>
+            <a:r>
+              <a:t>dashboard pages</a:t>
+            </a:r>
+          </a:p>
+        </p:txBody>
+      </p:sp>
+      <p:sp>
+        <p:nvSpPr>
+          <p:cNvPr id="15" name="Rounded Rectangle 14"/>
           <p:cNvSpPr/>
           <p:nvPr/>
         </p:nvSpPr>
         <p:spPr>
           <a:xfrm>
-            <a:off x="8138160" y="1417320"/>
-            <a:ext cx="73152" cy="3429000"/>
+            <a:off x="9281160" y="1508760"/>
+            <a:ext cx="2423160" cy="1508760"/>
+          </a:xfrm>
+          <a:prstGeom prst="roundRect">
+            <a:avLst/>
+          </a:prstGeom>
+          <a:solidFill>
+            <a:srgbClr val="F3F7F8"/>
+          </a:solidFill>
+          <a:ln>
+            <a:solidFill>
+              <a:srgbClr val="DCE5E8"/>
+            </a:solidFill>
+          </a:ln>
+        </p:spPr>
+        <p:style>
+          <a:lnRef idx="1">
+            <a:schemeClr val="accent1"/>
+          </a:lnRef>
+          <a:fillRef idx="3">
+            <a:schemeClr val="accent1"/>
+          </a:fillRef>
+          <a:effectRef idx="2">
+            <a:schemeClr val="accent1"/>
+          </a:effectRef>
+          <a:fontRef idx="minor">
+            <a:schemeClr val="lt1"/>
+          </a:fontRef>
+        </p:style>
+        <p:txBody>
+          <a:bodyPr rtlCol="0" anchor="ctr"/>
+          <a:lstStyle/>
+          <a:p>
+            <a:pPr algn="ctr"/>
+          </a:p>
+        </p:txBody>
+      </p:sp>
+      <p:sp>
+        <p:nvSpPr>
+          <p:cNvPr id="16" name="TextBox 15"/>
+          <p:cNvSpPr txBox="1"/>
+          <p:nvPr/>
+        </p:nvSpPr>
+        <p:spPr>
+          <a:xfrm>
+            <a:off x="9418320" y="1719072"/>
+            <a:ext cx="2148840" cy="502920"/>
+          </a:xfrm>
+          <a:prstGeom prst="rect">
+            <a:avLst/>
+          </a:prstGeom>
+          <a:noFill/>
+        </p:spPr>
+        <p:txBody>
+          <a:bodyPr wrap="square" lIns="36576" rIns="36576" anchor="ctr">
+            <a:spAutoFit/>
+          </a:bodyPr>
+          <a:lstStyle/>
+          <a:p>
+            <a:pPr algn="ctr">
+              <a:defRPr sz="3000" b="1">
+                <a:solidFill>
+                  <a:srgbClr val="FAB219"/>
+                </a:solidFill>
+                <a:latin typeface="Aptos"/>
+              </a:defRPr>
+            </a:pPr>
+            <a:r>
+              <a:t>4</a:t>
+            </a:r>
+          </a:p>
+        </p:txBody>
+      </p:sp>
+      <p:sp>
+        <p:nvSpPr>
+          <p:cNvPr id="17" name="TextBox 16"/>
+          <p:cNvSpPr txBox="1"/>
+          <p:nvPr/>
+        </p:nvSpPr>
+        <p:spPr>
+          <a:xfrm>
+            <a:off x="9418320" y="2331720"/>
+            <a:ext cx="2148840" cy="256032"/>
+          </a:xfrm>
+          <a:prstGeom prst="rect">
+            <a:avLst/>
+          </a:prstGeom>
+          <a:noFill/>
+        </p:spPr>
+        <p:txBody>
+          <a:bodyPr wrap="square" lIns="36576" rIns="36576" anchor="ctr">
+            <a:spAutoFit/>
+          </a:bodyPr>
+          <a:lstStyle/>
+          <a:p>
+            <a:pPr algn="ctr">
+              <a:defRPr sz="1200" b="1">
+                <a:solidFill>
+                  <a:srgbClr val="162B43"/>
+                </a:solidFill>
+                <a:latin typeface="Aptos"/>
+              </a:defRPr>
+            </a:pPr>
+            <a:r>
+              <a:t>user roles</a:t>
+            </a:r>
+          </a:p>
+        </p:txBody>
+      </p:sp>
+      <p:sp>
+        <p:nvSpPr>
+          <p:cNvPr id="18" name="Rounded Rectangle 17"/>
+          <p:cNvSpPr/>
+          <p:nvPr/>
+        </p:nvSpPr>
+        <p:spPr>
+          <a:xfrm>
+            <a:off x="960120" y="3657600"/>
+            <a:ext cx="4800600" cy="1417320"/>
+          </a:xfrm>
+          <a:prstGeom prst="roundRect">
+            <a:avLst/>
+          </a:prstGeom>
+          <a:solidFill>
+            <a:srgbClr val="F3F7F8"/>
+          </a:solidFill>
+          <a:ln>
+            <a:solidFill>
+              <a:srgbClr val="DCE5E8"/>
+            </a:solidFill>
+          </a:ln>
+        </p:spPr>
+        <p:style>
+          <a:lnRef idx="1">
+            <a:schemeClr val="accent1"/>
+          </a:lnRef>
+          <a:fillRef idx="3">
+            <a:schemeClr val="accent1"/>
+          </a:fillRef>
+          <a:effectRef idx="2">
+            <a:schemeClr val="accent1"/>
+          </a:effectRef>
+          <a:fontRef idx="minor">
+            <a:schemeClr val="lt1"/>
+          </a:fontRef>
+        </p:style>
+        <p:txBody>
+          <a:bodyPr rtlCol="0" anchor="ctr"/>
+          <a:lstStyle/>
+          <a:p>
+            <a:pPr algn="ctr"/>
+          </a:p>
+        </p:txBody>
+      </p:sp>
+      <p:sp>
+        <p:nvSpPr>
+          <p:cNvPr id="19" name="Rectangle 18"/>
+          <p:cNvSpPr/>
+          <p:nvPr/>
+        </p:nvSpPr>
+        <p:spPr>
+          <a:xfrm>
+            <a:off x="960120" y="3657600"/>
+            <a:ext cx="73152" cy="1417320"/>
+          </a:xfrm>
+          <a:prstGeom prst="rect">
+            <a:avLst/>
+          </a:prstGeom>
+          <a:solidFill>
+            <a:srgbClr val="0CA30C"/>
+          </a:solidFill>
+          <a:ln>
+            <a:noFill/>
+          </a:ln>
+        </p:spPr>
+        <p:style>
+          <a:lnRef idx="1">
+            <a:schemeClr val="accent1"/>
+          </a:lnRef>
+          <a:fillRef idx="3">
+            <a:schemeClr val="accent1"/>
+          </a:fillRef>
+          <a:effectRef idx="2">
+            <a:schemeClr val="accent1"/>
+          </a:effectRef>
+          <a:fontRef idx="minor">
+            <a:schemeClr val="lt1"/>
+          </a:fontRef>
+        </p:style>
+        <p:txBody>
+          <a:bodyPr rtlCol="0" anchor="ctr"/>
+          <a:lstStyle/>
+          <a:p>
+            <a:pPr algn="ctr"/>
+          </a:p>
+        </p:txBody>
+      </p:sp>
+      <p:sp>
+        <p:nvSpPr>
+          <p:cNvPr id="20" name="TextBox 19"/>
+          <p:cNvSpPr txBox="1"/>
+          <p:nvPr/>
+        </p:nvSpPr>
+        <p:spPr>
+          <a:xfrm>
+            <a:off x="1188720" y="3803904"/>
+            <a:ext cx="4389120" cy="310896"/>
+          </a:xfrm>
+          <a:prstGeom prst="rect">
+            <a:avLst/>
+          </a:prstGeom>
+          <a:noFill/>
+        </p:spPr>
+        <p:txBody>
+          <a:bodyPr wrap="square" lIns="36576" rIns="36576" anchor="ctr">
+            <a:spAutoFit/>
+          </a:bodyPr>
+          <a:lstStyle/>
+          <a:p>
+            <a:pPr algn="l">
+              <a:defRPr sz="1500" b="1">
+                <a:solidFill>
+                  <a:srgbClr val="162B43"/>
+                </a:solidFill>
+                <a:latin typeface="Aptos"/>
+              </a:defRPr>
+            </a:pPr>
+            <a:r>
+              <a:t>Compliance posture</a:t>
+            </a:r>
+          </a:p>
+        </p:txBody>
+      </p:sp>
+      <p:sp>
+        <p:nvSpPr>
+          <p:cNvPr id="21" name="TextBox 20"/>
+          <p:cNvSpPr txBox="1"/>
+          <p:nvPr/>
+        </p:nvSpPr>
+        <p:spPr>
+          <a:xfrm>
+            <a:off x="1188720" y="4187952"/>
+            <a:ext cx="4389120" cy="758952"/>
+          </a:xfrm>
+          <a:prstGeom prst="rect">
+            <a:avLst/>
+          </a:prstGeom>
+          <a:noFill/>
+        </p:spPr>
+        <p:txBody>
+          <a:bodyPr wrap="square" lIns="36576" rIns="36576" anchor="ctr">
+            <a:spAutoFit/>
+          </a:bodyPr>
+          <a:lstStyle/>
+          <a:p>
+            <a:pPr algn="l">
+              <a:defRPr sz="1300" b="0">
+                <a:solidFill>
+                  <a:srgbClr val="212D3A"/>
+                </a:solidFill>
+                <a:latin typeface="Aptos"/>
+              </a:defRPr>
+            </a:pPr>
+            <a:r>
+              <a:t>Overall compliance, non-compliant records, exceptions, and not-assessed populations.</a:t>
+            </a:r>
+          </a:p>
+        </p:txBody>
+      </p:sp>
+      <p:sp>
+        <p:nvSpPr>
+          <p:cNvPr id="22" name="Rounded Rectangle 21"/>
+          <p:cNvSpPr/>
+          <p:nvPr/>
+        </p:nvSpPr>
+        <p:spPr>
+          <a:xfrm>
+            <a:off x="6400800" y="3657600"/>
+            <a:ext cx="4800600" cy="1417320"/>
+          </a:xfrm>
+          <a:prstGeom prst="roundRect">
+            <a:avLst/>
+          </a:prstGeom>
+          <a:solidFill>
+            <a:srgbClr val="F3F7F8"/>
+          </a:solidFill>
+          <a:ln>
+            <a:solidFill>
+              <a:srgbClr val="DCE5E8"/>
+            </a:solidFill>
+          </a:ln>
+        </p:spPr>
+        <p:style>
+          <a:lnRef idx="1">
+            <a:schemeClr val="accent1"/>
+          </a:lnRef>
+          <a:fillRef idx="3">
+            <a:schemeClr val="accent1"/>
+          </a:fillRef>
+          <a:effectRef idx="2">
+            <a:schemeClr val="accent1"/>
+          </a:effectRef>
+          <a:fontRef idx="minor">
+            <a:schemeClr val="lt1"/>
+          </a:fontRef>
+        </p:style>
+        <p:txBody>
+          <a:bodyPr rtlCol="0" anchor="ctr"/>
+          <a:lstStyle/>
+          <a:p>
+            <a:pPr algn="ctr"/>
+          </a:p>
+        </p:txBody>
+      </p:sp>
+      <p:sp>
+        <p:nvSpPr>
+          <p:cNvPr id="23" name="Rectangle 22"/>
+          <p:cNvSpPr/>
+          <p:nvPr/>
+        </p:nvSpPr>
+        <p:spPr>
+          <a:xfrm>
+            <a:off x="6400800" y="3657600"/>
+            <a:ext cx="73152" cy="1417320"/>
           </a:xfrm>
           <a:prstGeom prst="rect">
             <a:avLst/>
@@ -11176,14 +11848,14 @@
       </p:sp>
       <p:sp>
         <p:nvSpPr>
-          <p:cNvPr id="16" name="TextBox 15"/>
-          <p:cNvSpPr txBox="1"/>
-          <p:nvPr/>
-        </p:nvSpPr>
-        <p:spPr>
-          <a:xfrm>
-            <a:off x="8366760" y="1563624"/>
-            <a:ext cx="2926079" cy="310896"/>
+          <p:cNvPr id="24" name="TextBox 23"/>
+          <p:cNvSpPr txBox="1"/>
+          <p:nvPr/>
+        </p:nvSpPr>
+        <p:spPr>
+          <a:xfrm>
+            <a:off x="6629400" y="3803904"/>
+            <a:ext cx="4389120" cy="310896"/>
           </a:xfrm>
           <a:prstGeom prst="rect">
             <a:avLst/>
@@ -11205,21 +11877,21 @@
               </a:defRPr>
             </a:pPr>
             <a:r>
-              <a:t>Access</a:t>
-            </a:r>
-          </a:p>
-        </p:txBody>
-      </p:sp>
-      <p:sp>
-        <p:nvSpPr>
-          <p:cNvPr id="17" name="TextBox 16"/>
-          <p:cNvSpPr txBox="1"/>
-          <p:nvPr/>
-        </p:nvSpPr>
-        <p:spPr>
-          <a:xfrm>
-            <a:off x="8366760" y="1947672"/>
-            <a:ext cx="2926079" cy="2770632"/>
+              <a:t>Control posture</a:t>
+            </a:r>
+          </a:p>
+        </p:txBody>
+      </p:sp>
+      <p:sp>
+        <p:nvSpPr>
+          <p:cNvPr id="25" name="TextBox 24"/>
+          <p:cNvSpPr txBox="1"/>
+          <p:nvPr/>
+        </p:nvSpPr>
+        <p:spPr>
+          <a:xfrm>
+            <a:off x="6629400" y="4187952"/>
+            <a:ext cx="4389120" cy="758952"/>
           </a:xfrm>
           <a:prstGeom prst="rect">
             <a:avLst/>
@@ -11233,7 +11905,7 @@
           <a:lstStyle/>
           <a:p>
             <a:pPr algn="l">
-              <a:defRPr sz="1400" b="0">
+              <a:defRPr sz="1300" b="0">
                 <a:solidFill>
                   <a:srgbClr val="212D3A"/>
                 </a:solidFill>
@@ -11241,55 +11913,14 @@
               </a:defRPr>
             </a:pPr>
             <a:r>
-              <a:t>Share the generated onrender.com URL with your office.</a:t>
-            </a:r>
-            <a:br/>
-            <a:br/>
-            <a:r>
-              <a:t>The free service may sleep when idle, so the first request can be slower.</a:t>
-            </a:r>
-          </a:p>
-        </p:txBody>
-      </p:sp>
-      <p:sp>
-        <p:nvSpPr>
-          <p:cNvPr id="18" name="TextBox 17"/>
-          <p:cNvSpPr txBox="1"/>
-          <p:nvPr/>
-        </p:nvSpPr>
-        <p:spPr>
-          <a:xfrm>
-            <a:off x="914400" y="5486400"/>
-            <a:ext cx="10332720" cy="384048"/>
-          </a:xfrm>
-          <a:prstGeom prst="rect">
-            <a:avLst/>
-          </a:prstGeom>
-          <a:noFill/>
-        </p:spPr>
-        <p:txBody>
-          <a:bodyPr wrap="square" lIns="36576" rIns="36576" anchor="ctr">
-            <a:spAutoFit/>
-          </a:bodyPr>
-          <a:lstStyle/>
-          <a:p>
-            <a:pPr algn="ctr">
-              <a:defRPr sz="1700" b="1">
-                <a:solidFill>
-                  <a:srgbClr val="D03B3B"/>
-                </a:solidFill>
-                <a:latin typeface="Aptos"/>
-              </a:defRPr>
-            </a:pPr>
-            <a:r>
-              <a:t>Recommended for prototype demonstrations; use private enterprise hosting for sensitive IAM data.</a:t>
-            </a:r>
-          </a:p>
-        </p:txBody>
-      </p:sp>
-      <p:sp>
-        <p:nvSpPr>
-          <p:cNvPr id="19" name="TextBox 18"/>
+              <a:t>PAM onboarding, password management, authentication integration, and risk ratings.</a:t>
+            </a:r>
+          </a:p>
+        </p:txBody>
+      </p:sp>
+      <p:sp>
+        <p:nvSpPr>
+          <p:cNvPr id="26" name="TextBox 25"/>
           <p:cNvSpPr txBox="1"/>
           <p:nvPr/>
         </p:nvSpPr>
@@ -11325,7 +11956,7 @@
       </p:sp>
       <p:sp>
         <p:nvSpPr>
-          <p:cNvPr id="20" name="TextBox 19"/>
+          <p:cNvPr id="27" name="TextBox 26"/>
           <p:cNvSpPr txBox="1"/>
           <p:nvPr/>
         </p:nvSpPr>
@@ -11451,7 +12082,7 @@
               </a:defRPr>
             </a:pPr>
             <a:r>
-              <a:t>Security posture</a:t>
+              <a:t>Deployment model</a:t>
             </a:r>
           </a:p>
         </p:txBody>
@@ -11487,7 +12118,7 @@
               </a:defRPr>
             </a:pPr>
             <a:r>
-              <a:t>IMPORTANT BOUNDARY</a:t>
+              <a:t>HOW TO SHARE THE DEMO</a:t>
             </a:r>
           </a:p>
         </p:txBody>
@@ -11543,8 +12174,8 @@
         </p:nvSpPr>
         <p:spPr>
           <a:xfrm>
-            <a:off x="685800" y="1417320"/>
-            <a:ext cx="5212080" cy="4069080"/>
+            <a:off x="731520" y="1417320"/>
+            <a:ext cx="3337560" cy="3429000"/>
           </a:xfrm>
           <a:prstGeom prst="roundRect">
             <a:avLst/>
@@ -11588,14 +12219,14 @@
         </p:nvSpPr>
         <p:spPr>
           <a:xfrm>
-            <a:off x="685800" y="1417320"/>
-            <a:ext cx="73152" cy="4069080"/>
+            <a:off x="731520" y="1417320"/>
+            <a:ext cx="73152" cy="3429000"/>
           </a:xfrm>
           <a:prstGeom prst="rect">
             <a:avLst/>
           </a:prstGeom>
           <a:solidFill>
-            <a:srgbClr val="FAB219"/>
+            <a:srgbClr val="162B43"/>
           </a:solidFill>
           <a:ln>
             <a:noFill/>
@@ -11631,8 +12262,8 @@
         </p:nvSpPr>
         <p:spPr>
           <a:xfrm>
-            <a:off x="914400" y="1563624"/>
-            <a:ext cx="4800600" cy="310896"/>
+            <a:off x="960120" y="1563624"/>
+            <a:ext cx="2926079" cy="310896"/>
           </a:xfrm>
           <a:prstGeom prst="rect">
             <a:avLst/>
@@ -11654,7 +12285,7 @@
               </a:defRPr>
             </a:pPr>
             <a:r>
-              <a:t>Current prototype</a:t>
+              <a:t>Source</a:t>
             </a:r>
           </a:p>
         </p:txBody>
@@ -11667,8 +12298,8 @@
         </p:nvSpPr>
         <p:spPr>
           <a:xfrm>
-            <a:off x="914400" y="1947672"/>
-            <a:ext cx="4800600" cy="3410712"/>
+            <a:off x="960120" y="1947672"/>
+            <a:ext cx="2926079" cy="2770632"/>
           </a:xfrm>
           <a:prstGeom prst="rect">
             <a:avLst/>
@@ -11682,7 +12313,7 @@
           <a:lstStyle/>
           <a:p>
             <a:pPr algn="l">
-              <a:defRPr sz="1500" b="0">
+              <a:defRPr sz="1400" b="0">
                 <a:solidFill>
                   <a:srgbClr val="212D3A"/>
                 </a:solidFill>
@@ -11690,23 +12321,17 @@
               </a:defRPr>
             </a:pPr>
             <a:r>
-              <a:t>• Demo credentials in project data</a:t>
+              <a:t>GitHub repository</a:t>
             </a:r>
             <a:br/>
-            <a:r>
-              <a:t>• Session-based browser state</a:t>
-            </a:r>
             <a:br/>
             <a:r>
-              <a:t>• CSV-backed sample data</a:t>
+              <a:t>2025aa05980/compliance-dashboard</a:t>
             </a:r>
             <a:br/>
-            <a:r>
-              <a:t>• UI role filtering</a:t>
-            </a:r>
             <a:br/>
             <a:r>
-              <a:t>• Suitable for non-sensitive demonstrations</a:t>
+              <a:t>Versioned source, requirements, data, and Render configuration.</a:t>
             </a:r>
           </a:p>
         </p:txBody>
@@ -11719,8 +12344,8 @@
         </p:nvSpPr>
         <p:spPr>
           <a:xfrm>
-            <a:off x="6263640" y="1417320"/>
-            <a:ext cx="5212080" cy="4069080"/>
+            <a:off x="4434840" y="1417320"/>
+            <a:ext cx="3337560" cy="3429000"/>
           </a:xfrm>
           <a:prstGeom prst="roundRect">
             <a:avLst/>
@@ -11764,14 +12389,14 @@
         </p:nvSpPr>
         <p:spPr>
           <a:xfrm>
-            <a:off x="6263640" y="1417320"/>
-            <a:ext cx="73152" cy="4069080"/>
+            <a:off x="4434840" y="1417320"/>
+            <a:ext cx="73152" cy="3429000"/>
           </a:xfrm>
           <a:prstGeom prst="rect">
             <a:avLst/>
           </a:prstGeom>
           <a:solidFill>
-            <a:srgbClr val="0CA30C"/>
+            <a:srgbClr val="009196"/>
           </a:solidFill>
           <a:ln>
             <a:noFill/>
@@ -11807,8 +12432,8 @@
         </p:nvSpPr>
         <p:spPr>
           <a:xfrm>
-            <a:off x="6492240" y="1563624"/>
-            <a:ext cx="4800600" cy="310896"/>
+            <a:off x="4663440" y="1563624"/>
+            <a:ext cx="2926079" cy="310896"/>
           </a:xfrm>
           <a:prstGeom prst="rect">
             <a:avLst/>
@@ -11830,7 +12455,7 @@
               </a:defRPr>
             </a:pPr>
             <a:r>
-              <a:t>Production target</a:t>
+              <a:t>Build</a:t>
             </a:r>
           </a:p>
         </p:txBody>
@@ -11843,8 +12468,8 @@
         </p:nvSpPr>
         <p:spPr>
           <a:xfrm>
-            <a:off x="6492240" y="1947672"/>
-            <a:ext cx="4800600" cy="3410712"/>
+            <a:off x="4663440" y="1947672"/>
+            <a:ext cx="2926079" cy="2770632"/>
           </a:xfrm>
           <a:prstGeom prst="rect">
             <a:avLst/>
@@ -11858,7 +12483,7 @@
           <a:lstStyle/>
           <a:p>
             <a:pPr algn="l">
-              <a:defRPr sz="1500" b="0">
+              <a:defRPr sz="1400" b="0">
                 <a:solidFill>
                   <a:srgbClr val="212D3A"/>
                 </a:solidFill>
@@ -11866,41 +12491,196 @@
               </a:defRPr>
             </a:pPr>
             <a:r>
-              <a:t>• Entra ID / Okta SSO and MFA</a:t>
+              <a:t>Render installs requirements.txt and runs:</a:t>
             </a:r>
             <a:br/>
-            <a:r>
-              <a:t>• Server-side signed sessions</a:t>
-            </a:r>
             <a:br/>
             <a:r>
-              <a:t>• Backend authorization on callbacks</a:t>
+              <a:t>Gunicorn app:server</a:t>
             </a:r>
             <a:br/>
-            <a:r>
-              <a:t>• Hashed credentials or no local passwords</a:t>
-            </a:r>
             <a:br/>
             <a:r>
-              <a:t>• Secure database / APIs</a:t>
+              <a:t>The Dash WSGI server is exposed over HTTPS.</a:t>
+            </a:r>
+          </a:p>
+        </p:txBody>
+      </p:sp>
+      <p:sp>
+        <p:nvSpPr>
+          <p:cNvPr id="14" name="Rounded Rectangle 13"/>
+          <p:cNvSpPr/>
+          <p:nvPr/>
+        </p:nvSpPr>
+        <p:spPr>
+          <a:xfrm>
+            <a:off x="8138160" y="1417320"/>
+            <a:ext cx="3337560" cy="3429000"/>
+          </a:xfrm>
+          <a:prstGeom prst="roundRect">
+            <a:avLst/>
+          </a:prstGeom>
+          <a:solidFill>
+            <a:srgbClr val="F3F7F8"/>
+          </a:solidFill>
+          <a:ln>
+            <a:solidFill>
+              <a:srgbClr val="DCE5E8"/>
+            </a:solidFill>
+          </a:ln>
+        </p:spPr>
+        <p:style>
+          <a:lnRef idx="1">
+            <a:schemeClr val="accent1"/>
+          </a:lnRef>
+          <a:fillRef idx="3">
+            <a:schemeClr val="accent1"/>
+          </a:fillRef>
+          <a:effectRef idx="2">
+            <a:schemeClr val="accent1"/>
+          </a:effectRef>
+          <a:fontRef idx="minor">
+            <a:schemeClr val="lt1"/>
+          </a:fontRef>
+        </p:style>
+        <p:txBody>
+          <a:bodyPr rtlCol="0" anchor="ctr"/>
+          <a:lstStyle/>
+          <a:p>
+            <a:pPr algn="ctr"/>
+          </a:p>
+        </p:txBody>
+      </p:sp>
+      <p:sp>
+        <p:nvSpPr>
+          <p:cNvPr id="15" name="Rectangle 14"/>
+          <p:cNvSpPr/>
+          <p:nvPr/>
+        </p:nvSpPr>
+        <p:spPr>
+          <a:xfrm>
+            <a:off x="8138160" y="1417320"/>
+            <a:ext cx="73152" cy="3429000"/>
+          </a:xfrm>
+          <a:prstGeom prst="rect">
+            <a:avLst/>
+          </a:prstGeom>
+          <a:solidFill>
+            <a:srgbClr val="2A78D6"/>
+          </a:solidFill>
+          <a:ln>
+            <a:noFill/>
+          </a:ln>
+        </p:spPr>
+        <p:style>
+          <a:lnRef idx="1">
+            <a:schemeClr val="accent1"/>
+          </a:lnRef>
+          <a:fillRef idx="3">
+            <a:schemeClr val="accent1"/>
+          </a:fillRef>
+          <a:effectRef idx="2">
+            <a:schemeClr val="accent1"/>
+          </a:effectRef>
+          <a:fontRef idx="minor">
+            <a:schemeClr val="lt1"/>
+          </a:fontRef>
+        </p:style>
+        <p:txBody>
+          <a:bodyPr rtlCol="0" anchor="ctr"/>
+          <a:lstStyle/>
+          <a:p>
+            <a:pPr algn="ctr"/>
+          </a:p>
+        </p:txBody>
+      </p:sp>
+      <p:sp>
+        <p:nvSpPr>
+          <p:cNvPr id="16" name="TextBox 15"/>
+          <p:cNvSpPr txBox="1"/>
+          <p:nvPr/>
+        </p:nvSpPr>
+        <p:spPr>
+          <a:xfrm>
+            <a:off x="8366760" y="1563624"/>
+            <a:ext cx="2926079" cy="310896"/>
+          </a:xfrm>
+          <a:prstGeom prst="rect">
+            <a:avLst/>
+          </a:prstGeom>
+          <a:noFill/>
+        </p:spPr>
+        <p:txBody>
+          <a:bodyPr wrap="square" lIns="36576" rIns="36576" anchor="ctr">
+            <a:spAutoFit/>
+          </a:bodyPr>
+          <a:lstStyle/>
+          <a:p>
+            <a:pPr algn="l">
+              <a:defRPr sz="1500" b="1">
+                <a:solidFill>
+                  <a:srgbClr val="162B43"/>
+                </a:solidFill>
+                <a:latin typeface="Aptos"/>
+              </a:defRPr>
+            </a:pPr>
+            <a:r>
+              <a:t>Access</a:t>
+            </a:r>
+          </a:p>
+        </p:txBody>
+      </p:sp>
+      <p:sp>
+        <p:nvSpPr>
+          <p:cNvPr id="17" name="TextBox 16"/>
+          <p:cNvSpPr txBox="1"/>
+          <p:nvPr/>
+        </p:nvSpPr>
+        <p:spPr>
+          <a:xfrm>
+            <a:off x="8366760" y="1947672"/>
+            <a:ext cx="2926079" cy="2770632"/>
+          </a:xfrm>
+          <a:prstGeom prst="rect">
+            <a:avLst/>
+          </a:prstGeom>
+          <a:noFill/>
+        </p:spPr>
+        <p:txBody>
+          <a:bodyPr wrap="square" lIns="36576" rIns="36576" anchor="ctr">
+            <a:spAutoFit/>
+          </a:bodyPr>
+          <a:lstStyle/>
+          <a:p>
+            <a:pPr algn="l">
+              <a:defRPr sz="1400" b="0">
+                <a:solidFill>
+                  <a:srgbClr val="212D3A"/>
+                </a:solidFill>
+                <a:latin typeface="Aptos"/>
+              </a:defRPr>
+            </a:pPr>
+            <a:r>
+              <a:t>Share the generated onrender.com URL with your office.</a:t>
             </a:r>
             <a:br/>
-            <a:r>
-              <a:t>• Audit logs, secrets management, private hosting</a:t>
-            </a:r>
-          </a:p>
-        </p:txBody>
-      </p:sp>
-      <p:sp>
-        <p:nvSpPr>
-          <p:cNvPr id="14" name="TextBox 13"/>
-          <p:cNvSpPr txBox="1"/>
-          <p:nvPr/>
-        </p:nvSpPr>
-        <p:spPr>
-          <a:xfrm>
-            <a:off x="914400" y="5760720"/>
-            <a:ext cx="10332720" cy="365760"/>
+            <a:br/>
+            <a:r>
+              <a:t>The free service may sleep when idle, so the first request can be slower.</a:t>
+            </a:r>
+          </a:p>
+        </p:txBody>
+      </p:sp>
+      <p:sp>
+        <p:nvSpPr>
+          <p:cNvPr id="18" name="TextBox 17"/>
+          <p:cNvSpPr txBox="1"/>
+          <p:nvPr/>
+        </p:nvSpPr>
+        <p:spPr>
+          <a:xfrm>
+            <a:off x="914400" y="5486400"/>
+            <a:ext cx="10332720" cy="384048"/>
           </a:xfrm>
           <a:prstGeom prst="rect">
             <a:avLst/>
@@ -11914,22 +12694,22 @@
           <a:lstStyle/>
           <a:p>
             <a:pPr algn="ctr">
-              <a:defRPr sz="1500" b="1">
-                <a:solidFill>
-                  <a:srgbClr val="162B43"/>
-                </a:solidFill>
-                <a:latin typeface="Aptos"/>
-              </a:defRPr>
-            </a:pPr>
-            <a:r>
-              <a:t>Conclusion: Dash is a reasonable internal dashboard framework; this implementation requires hardening before restricted production use.</a:t>
-            </a:r>
-          </a:p>
-        </p:txBody>
-      </p:sp>
-      <p:sp>
-        <p:nvSpPr>
-          <p:cNvPr id="15" name="TextBox 14"/>
+              <a:defRPr sz="1700" b="1">
+                <a:solidFill>
+                  <a:srgbClr val="D03B3B"/>
+                </a:solidFill>
+                <a:latin typeface="Aptos"/>
+              </a:defRPr>
+            </a:pPr>
+            <a:r>
+              <a:t>Recommended for prototype demonstrations; use private enterprise hosting for sensitive IAM data.</a:t>
+            </a:r>
+          </a:p>
+        </p:txBody>
+      </p:sp>
+      <p:sp>
+        <p:nvSpPr>
+          <p:cNvPr id="19" name="TextBox 18"/>
           <p:cNvSpPr txBox="1"/>
           <p:nvPr/>
         </p:nvSpPr>
@@ -11965,7 +12745,7 @@
       </p:sp>
       <p:sp>
         <p:nvSpPr>
-          <p:cNvPr id="16" name="TextBox 15"/>
+          <p:cNvPr id="20" name="TextBox 19"/>
           <p:cNvSpPr txBox="1"/>
           <p:nvPr/>
         </p:nvSpPr>

</xml_diff>